<commit_message>
docs: restructure slide deck to follow abstract, problem statement, reqs, architecture, frontend design structure
</commit_message>
<xml_diff>
--- a/medicare_presentation.pptx
+++ b/medicare_presentation.pptx
@@ -3111,8 +3111,8 @@
         </p:nvSpPr>
         <p:spPr>
           <a:xfrm>
-            <a:off x="914400" y="2011680"/>
-            <a:ext cx="10360152" cy="3200400"/>
+            <a:off x="914400" y="1828800"/>
+            <a:ext cx="10360152" cy="3657600"/>
           </a:xfrm>
           <a:prstGeom prst="rect">
             <a:avLst/>
@@ -3166,7 +3166,7 @@
               </a:defRPr>
             </a:pPr>
             <a:r>
-              <a:t>Offline-First Medicine Adherence &amp; Safety Platform</a:t>
+              <a:t>Project Presentation Slide Deck</a:t>
             </a:r>
           </a:p>
         </p:txBody>
@@ -3228,7 +3228,7 @@
               </a:defRPr>
             </a:pPr>
             <a:r>
-              <a:t>The Problem We Solve</a:t>
+              <a:t>1. Abstract of Project</a:t>
             </a:r>
           </a:p>
         </p:txBody>
@@ -3257,33 +3257,17 @@
           <a:p>
             <a:pPr>
               <a:spcAft>
-                <a:spcPts val="2000"/>
+                <a:spcPts val="1500"/>
               </a:spcAft>
               <a:defRPr sz="1800">
                 <a:solidFill>
-                  <a:srgbClr val="9CA3AF"/>
+                  <a:srgbClr val="FFFFFF"/>
                 </a:solidFill>
                 <a:latin typeface="Plus Jakarta Sans"/>
               </a:defRPr>
             </a:pPr>
             <a:r>
-              <a:t>Elderly medication non-adherence and delayed responses to critical health events lead to high safety risks.</a:t>
-            </a:r>
-          </a:p>
-          <a:p>
-            <a:pPr>
-              <a:spcBef>
-                <a:spcPts val="1000"/>
-              </a:spcBef>
-              <a:defRPr sz="2000" b="1">
-                <a:solidFill>
-                  <a:srgbClr val="F43F5E"/>
-                </a:solidFill>
-                <a:latin typeface="Outfit"/>
-              </a:defRPr>
-            </a:pPr>
-            <a:r>
-              <a:t>• Elderly Forgetfulness &amp; Safety Risks</a:t>
+              <a:t>The MediCare Reminder System (Aegis Health) is an offline-first, highly responsive web application built to enhance medication compliance and ensure safety for elderly patients.</a:t>
             </a:r>
           </a:p>
           <a:p>
@@ -3291,79 +3275,79 @@
               <a:spcAft>
                 <a:spcPts val="1000"/>
               </a:spcAft>
-              <a:defRPr sz="1600">
-                <a:solidFill>
-                  <a:srgbClr val="FFFFFF"/>
-                </a:solidFill>
-                <a:latin typeface="Plus Jakarta Sans"/>
-              </a:defRPr>
-            </a:pPr>
-            <a:r>
-              <a:t>   Seniors frequently miss due doses, take wrong quantities, or double-dose medication due to memory loss.</a:t>
-            </a:r>
-          </a:p>
-          <a:p>
-            <a:pPr>
-              <a:spcBef>
-                <a:spcPts val="1000"/>
-              </a:spcBef>
-              <a:defRPr sz="2000" b="1">
-                <a:solidFill>
-                  <a:srgbClr val="F43F5E"/>
+              <a:defRPr sz="1800" b="1">
+                <a:solidFill>
+                  <a:srgbClr val="0D9488"/>
                 </a:solidFill>
                 <a:latin typeface="Outfit"/>
               </a:defRPr>
             </a:pPr>
             <a:r>
-              <a:t>• No Direct Emergency Triggers</a:t>
+              <a:t>Key highlights include:</a:t>
             </a:r>
           </a:p>
           <a:p>
             <a:pPr>
               <a:spcAft>
-                <a:spcPts val="1000"/>
+                <a:spcPts val="800"/>
               </a:spcAft>
               <a:defRPr sz="1600">
                 <a:solidFill>
-                  <a:srgbClr val="FFFFFF"/>
+                  <a:srgbClr val="9CA3AF"/>
                 </a:solidFill>
                 <a:latin typeface="Plus Jakarta Sans"/>
               </a:defRPr>
             </a:pPr>
             <a:r>
-              <a:t>   Lack of easy-access emergency contacts, helpline numbers, or direct call buttons to doctors in times of immediate crisis.</a:t>
-            </a:r>
-          </a:p>
-          <a:p>
-            <a:pPr>
-              <a:spcBef>
-                <a:spcPts val="1000"/>
-              </a:spcBef>
-              <a:defRPr sz="2000" b="1">
-                <a:solidFill>
-                  <a:srgbClr val="F43F5E"/>
-                </a:solidFill>
-                <a:latin typeface="Outfit"/>
-              </a:defRPr>
-            </a:pPr>
-            <a:r>
-              <a:t>• Laggy Apps &amp; Offline Issues</a:t>
+              <a:t>• Optimistic UI updates through local Firestore IndexedDB caching, eliminating database save lags.</a:t>
             </a:r>
           </a:p>
           <a:p>
             <a:pPr>
               <a:spcAft>
-                <a:spcPts val="1000"/>
+                <a:spcPts val="800"/>
               </a:spcAft>
               <a:defRPr sz="1600">
                 <a:solidFill>
-                  <a:srgbClr val="FFFFFF"/>
+                  <a:srgbClr val="9CA3AF"/>
                 </a:solidFill>
                 <a:latin typeface="Plus Jakarta Sans"/>
               </a:defRPr>
             </a:pPr>
             <a:r>
-              <a:t>   Traditional online health platforms fail, freeze, or lag when internet connectivity fluctuates, leading to data syncing failures.</a:t>
+              <a:t>• Dynamic multi-language support localized in Telugu and Hindi for dynamic checkboxes and details.</a:t>
+            </a:r>
+          </a:p>
+          <a:p>
+            <a:pPr>
+              <a:spcAft>
+                <a:spcPts val="800"/>
+              </a:spcAft>
+              <a:defRPr sz="1600">
+                <a:solidFill>
+                  <a:srgbClr val="9CA3AF"/>
+                </a:solidFill>
+                <a:latin typeface="Plus Jakarta Sans"/>
+              </a:defRPr>
+            </a:pPr>
+            <a:r>
+              <a:t>• Tactile dose reminders with built-in instant dialing links for primary doctors and emergency caretakers.</a:t>
+            </a:r>
+          </a:p>
+          <a:p>
+            <a:pPr>
+              <a:spcAft>
+                <a:spcPts val="800"/>
+              </a:spcAft>
+              <a:defRPr sz="1600">
+                <a:solidFill>
+                  <a:srgbClr val="9CA3AF"/>
+                </a:solidFill>
+                <a:latin typeface="Plus Jakarta Sans"/>
+              </a:defRPr>
+            </a:pPr>
+            <a:r>
+              <a:t>• Emergency SOS triggers linked to real-time caregiver grids to monitor compliance and check-ups.</a:t>
             </a:r>
           </a:p>
         </p:txBody>
@@ -3425,7 +3409,7 @@
               </a:defRPr>
             </a:pPr>
             <a:r>
-              <a:t>The Aegis Innovation</a:t>
+              <a:t>2. Problem Statement</a:t>
             </a:r>
           </a:p>
         </p:txBody>
@@ -3454,7 +3438,7 @@
           <a:p>
             <a:pPr>
               <a:spcAft>
-                <a:spcPts val="2000"/>
+                <a:spcPts val="1500"/>
               </a:spcAft>
               <a:defRPr sz="1800">
                 <a:solidFill>
@@ -3464,31 +3448,28 @@
               </a:defRPr>
             </a:pPr>
             <a:r>
-              <a:t>A modern, highly optimized wellness companion designed to act immediately in any scenario.</a:t>
+              <a:t>Seniors and patients facing complex prescription schedules encounter high safety risks due to several challenges:</a:t>
             </a:r>
           </a:p>
           <a:p>
             <a:pPr>
               <a:spcBef>
-                <a:spcPts val="1000"/>
+                <a:spcPts val="800"/>
               </a:spcBef>
-              <a:defRPr sz="2000" b="1">
-                <a:solidFill>
-                  <a:srgbClr val="0D9488"/>
+              <a:defRPr sz="1800" b="1">
+                <a:solidFill>
+                  <a:srgbClr val="F43F5E"/>
                 </a:solidFill>
                 <a:latin typeface="Outfit"/>
               </a:defRPr>
             </a:pPr>
             <a:r>
-              <a:t>• Zero-Lag Offline Persistence</a:t>
-            </a:r>
-          </a:p>
-          <a:p>
-            <a:pPr>
-              <a:spcAft>
-                <a:spcPts val="1000"/>
-              </a:spcAft>
-              <a:defRPr sz="1600">
+              <a:t>• Medication Forgetfulness</a:t>
+            </a:r>
+          </a:p>
+          <a:p>
+            <a:pPr>
+              <a:defRPr sz="1500">
                 <a:solidFill>
                   <a:srgbClr val="FFFFFF"/>
                 </a:solidFill>
@@ -3496,31 +3477,28 @@
               </a:defRPr>
             </a:pPr>
             <a:r>
-              <a:t>   Firestore IndexedDB local sync updates the UI immediately. Actions are recorded instantly and synced later when connection returns.</a:t>
+              <a:t>   Elderly patients skip scheduled doses or double-dose medication due to cognitive or memory declines.</a:t>
             </a:r>
           </a:p>
           <a:p>
             <a:pPr>
               <a:spcBef>
-                <a:spcPts val="1000"/>
+                <a:spcPts val="800"/>
               </a:spcBef>
-              <a:defRPr sz="2000" b="1">
-                <a:solidFill>
-                  <a:srgbClr val="0D9488"/>
+              <a:defRPr sz="1800" b="1">
+                <a:solidFill>
+                  <a:srgbClr val="F43F5E"/>
                 </a:solidFill>
                 <a:latin typeface="Outfit"/>
               </a:defRPr>
             </a:pPr>
             <a:r>
-              <a:t>• One-Click Emergency Call &amp; SOS</a:t>
-            </a:r>
-          </a:p>
-          <a:p>
-            <a:pPr>
-              <a:spcAft>
-                <a:spcPts val="1000"/>
-              </a:spcAft>
-              <a:defRPr sz="1600">
+              <a:t>• Sluggish Portal Latencies</a:t>
+            </a:r>
+          </a:p>
+          <a:p>
+            <a:pPr>
+              <a:defRPr sz="1500">
                 <a:solidFill>
                   <a:srgbClr val="FFFFFF"/>
                 </a:solidFill>
@@ -3528,31 +3506,28 @@
               </a:defRPr>
             </a:pPr>
             <a:r>
-              <a:t>   Direct doctor calling links and a dedicated SOS interface play loud siren warnings and alert linked caregivers immediately.</a:t>
+              <a:t>   Standard online portals block the UI and lag when trying to save data during unstable network operations.</a:t>
             </a:r>
           </a:p>
           <a:p>
             <a:pPr>
               <a:spcBef>
-                <a:spcPts val="1000"/>
+                <a:spcPts val="800"/>
               </a:spcBef>
-              <a:defRPr sz="2000" b="1">
-                <a:solidFill>
-                  <a:srgbClr val="0D9488"/>
+              <a:defRPr sz="1800" b="1">
+                <a:solidFill>
+                  <a:srgbClr val="F43F5E"/>
                 </a:solidFill>
                 <a:latin typeface="Outfit"/>
               </a:defRPr>
             </a:pPr>
             <a:r>
-              <a:t>• Dynamic Multi-Language System</a:t>
-            </a:r>
-          </a:p>
-          <a:p>
-            <a:pPr>
-              <a:spcAft>
-                <a:spcPts val="1000"/>
-              </a:spcAft>
-              <a:defRPr sz="1600">
+              <a:t>• No Direct Dials in Emergency</a:t>
+            </a:r>
+          </a:p>
+          <a:p>
+            <a:pPr>
+              <a:defRPr sz="1500">
                 <a:solidFill>
                   <a:srgbClr val="FFFFFF"/>
                 </a:solidFill>
@@ -3560,7 +3535,36 @@
               </a:defRPr>
             </a:pPr>
             <a:r>
-              <a:t>   Full custom Telugu &amp; Hindi dynamically localized interfaces. Even dynamic checklists update in the native selected language.</a:t>
+              <a:t>   Traditional checklists do not offer instant emergency calling features for caregivers or doctors during crises.</a:t>
+            </a:r>
+          </a:p>
+          <a:p>
+            <a:pPr>
+              <a:spcBef>
+                <a:spcPts val="800"/>
+              </a:spcBef>
+              <a:defRPr sz="1800" b="1">
+                <a:solidFill>
+                  <a:srgbClr val="F43F5E"/>
+                </a:solidFill>
+                <a:latin typeface="Outfit"/>
+              </a:defRPr>
+            </a:pPr>
+            <a:r>
+              <a:t>• Lack of Localization</a:t>
+            </a:r>
+          </a:p>
+          <a:p>
+            <a:pPr>
+              <a:defRPr sz="1500">
+                <a:solidFill>
+                  <a:srgbClr val="FFFFFF"/>
+                </a:solidFill>
+                <a:latin typeface="Plus Jakarta Sans"/>
+              </a:defRPr>
+            </a:pPr>
+            <a:r>
+              <a:t>   Important instructions and checklists do not translate dynamic database entries into local languages (Telugu &amp; Hindi).</a:t>
             </a:r>
           </a:p>
         </p:txBody>
@@ -3622,7 +3626,7 @@
               </a:defRPr>
             </a:pPr>
             <a:r>
-              <a:t>Modern Splash &amp; Branding</a:t>
+              <a:t>3. Existing and Proposed System</a:t>
             </a:r>
           </a:p>
         </p:txBody>
@@ -3636,7 +3640,7 @@
         <p:spPr>
           <a:xfrm>
             <a:off x="914400" y="1645920"/>
-            <a:ext cx="5486400" cy="4572000"/>
+            <a:ext cx="4754880" cy="4572000"/>
           </a:xfrm>
           <a:prstGeom prst="rect">
             <a:avLst/>
@@ -3650,18 +3654,18 @@
           <a:lstStyle/>
           <a:p>
             <a:pPr>
-              <a:spcBef>
-                <a:spcPts val="1000"/>
-              </a:spcBef>
-              <a:defRPr sz="1800" b="1">
-                <a:solidFill>
-                  <a:srgbClr val="0D9488"/>
+              <a:spcAft>
+                <a:spcPts val="1500"/>
+              </a:spcAft>
+              <a:defRPr sz="2200" b="1">
+                <a:solidFill>
+                  <a:srgbClr val="F43F5E"/>
                 </a:solidFill>
                 <a:latin typeface="Outfit"/>
               </a:defRPr>
             </a:pPr>
             <a:r>
-              <a:t>• Curated Dark Theme UI</a:t>
+              <a:t>Existing Systems</a:t>
             </a:r>
           </a:p>
           <a:p>
@@ -3671,29 +3675,13 @@
               </a:spcAft>
               <a:defRPr sz="1500">
                 <a:solidFill>
-                  <a:srgbClr val="FFFFFF"/>
+                  <a:srgbClr val="9CA3AF"/>
                 </a:solidFill>
                 <a:latin typeface="Plus Jakarta Sans"/>
               </a:defRPr>
             </a:pPr>
             <a:r>
-              <a:t>   Deep charcoal gradient backgrounds and bright, high-contrast cyan indicators ensure readability for senior eyes.</a:t>
-            </a:r>
-          </a:p>
-          <a:p>
-            <a:pPr>
-              <a:spcBef>
-                <a:spcPts val="1000"/>
-              </a:spcBef>
-              <a:defRPr sz="1800" b="1">
-                <a:solidFill>
-                  <a:srgbClr val="0D9488"/>
-                </a:solidFill>
-                <a:latin typeface="Outfit"/>
-              </a:defRPr>
-            </a:pPr>
-            <a:r>
-              <a:t>• Responsive Smartphone Interface</a:t>
+              <a:t>• Manual paper logs or static spreadsheets subject to loss or misplacement.</a:t>
             </a:r>
           </a:p>
           <a:p>
@@ -3703,29 +3691,13 @@
               </a:spcAft>
               <a:defRPr sz="1500">
                 <a:solidFill>
-                  <a:srgbClr val="FFFFFF"/>
+                  <a:srgbClr val="9CA3AF"/>
                 </a:solidFill>
                 <a:latin typeface="Plus Jakarta Sans"/>
               </a:defRPr>
             </a:pPr>
             <a:r>
-              <a:t>   Built to adapt natively to all smartphone viewports, offering a premium and uncluttered dashboard access portal.</a:t>
-            </a:r>
-          </a:p>
-          <a:p>
-            <a:pPr>
-              <a:spcBef>
-                <a:spcPts val="1000"/>
-              </a:spcBef>
-              <a:defRPr sz="1800" b="1">
-                <a:solidFill>
-                  <a:srgbClr val="0D9488"/>
-                </a:solidFill>
-                <a:latin typeface="Outfit"/>
-              </a:defRPr>
-            </a:pPr>
-            <a:r>
-              <a:t>• Patient &amp; Caregiver Sign-ins</a:t>
+              <a:t>• Cloud-only apps that freeze during slow internet operations and throw database errors.</a:t>
             </a:r>
           </a:p>
           <a:p>
@@ -3735,41 +3707,136 @@
               </a:spcAft>
               <a:defRPr sz="1500">
                 <a:solidFill>
-                  <a:srgbClr val="FFFFFF"/>
+                  <a:srgbClr val="9CA3AF"/>
                 </a:solidFill>
                 <a:latin typeface="Plus Jakarta Sans"/>
               </a:defRPr>
             </a:pPr>
             <a:r>
-              <a:t>   Unified entry portal allows fast switching between patient tracker and caretaker monitoring screens.</a:t>
-            </a:r>
-          </a:p>
-        </p:txBody>
-      </p:sp>
-      <p:pic>
-        <p:nvPicPr>
-          <p:cNvPr id="4" name="Picture 3" descr="splash_screen.png"/>
-          <p:cNvPicPr>
-            <a:picLocks noChangeAspect="1"/>
-          </p:cNvPicPr>
+              <a:t>• Static checklists that cannot be easily read aloud or customized.</a:t>
+            </a:r>
+          </a:p>
+          <a:p>
+            <a:pPr>
+              <a:spcAft>
+                <a:spcPts val="1000"/>
+              </a:spcAft>
+              <a:defRPr sz="1500">
+                <a:solidFill>
+                  <a:srgbClr val="9CA3AF"/>
+                </a:solidFill>
+                <a:latin typeface="Plus Jakarta Sans"/>
+              </a:defRPr>
+            </a:pPr>
+            <a:r>
+              <a:t>• English-only platforms that pose barriers to rural or regional elderly users.</a:t>
+            </a:r>
+          </a:p>
+        </p:txBody>
+      </p:sp>
+      <p:sp>
+        <p:nvSpPr>
+          <p:cNvPr id="4" name="TextBox 3"/>
+          <p:cNvSpPr txBox="1"/>
           <p:nvPr/>
-        </p:nvPicPr>
-        <p:blipFill>
-          <a:blip r:embed="rId2"/>
-          <a:stretch>
-            <a:fillRect/>
-          </a:stretch>
-        </p:blipFill>
+        </p:nvSpPr>
         <p:spPr>
           <a:xfrm>
-            <a:off x="8046720" y="1097280"/>
-            <a:ext cx="2377440" cy="4754880"/>
+            <a:off x="6400800" y="1645920"/>
+            <a:ext cx="4846320" cy="4572000"/>
           </a:xfrm>
           <a:prstGeom prst="rect">
             <a:avLst/>
           </a:prstGeom>
+          <a:noFill/>
         </p:spPr>
-      </p:pic>
+        <p:txBody>
+          <a:bodyPr wrap="square">
+            <a:spAutoFit/>
+          </a:bodyPr>
+          <a:lstStyle/>
+          <a:p>
+            <a:pPr>
+              <a:spcAft>
+                <a:spcPts val="1500"/>
+              </a:spcAft>
+              <a:defRPr sz="2200" b="1">
+                <a:solidFill>
+                  <a:srgbClr val="0D9488"/>
+                </a:solidFill>
+                <a:latin typeface="Outfit"/>
+              </a:defRPr>
+            </a:pPr>
+            <a:r>
+              <a:t>Proposed System</a:t>
+            </a:r>
+          </a:p>
+          <a:p>
+            <a:pPr>
+              <a:spcAft>
+                <a:spcPts val="1000"/>
+              </a:spcAft>
+              <a:defRPr sz="1500">
+                <a:solidFill>
+                  <a:srgbClr val="FFFFFF"/>
+                </a:solidFill>
+                <a:latin typeface="Plus Jakarta Sans"/>
+              </a:defRPr>
+            </a:pPr>
+            <a:r>
+              <a:t>✓ Zero-Lag optimistic saving backed by Firestore Offline Persistence.</a:t>
+            </a:r>
+          </a:p>
+          <a:p>
+            <a:pPr>
+              <a:spcAft>
+                <a:spcPts val="1000"/>
+              </a:spcAft>
+              <a:defRPr sz="1500">
+                <a:solidFill>
+                  <a:srgbClr val="FFFFFF"/>
+                </a:solidFill>
+                <a:latin typeface="Plus Jakarta Sans"/>
+              </a:defRPr>
+            </a:pPr>
+            <a:r>
+              <a:t>✓ Instant tactile feedback: 50ms active button scale transitions and 100ms snappy modal openings.</a:t>
+            </a:r>
+          </a:p>
+          <a:p>
+            <a:pPr>
+              <a:spcAft>
+                <a:spcPts val="1000"/>
+              </a:spcAft>
+              <a:defRPr sz="1500">
+                <a:solidFill>
+                  <a:srgbClr val="FFFFFF"/>
+                </a:solidFill>
+                <a:latin typeface="Plus Jakarta Sans"/>
+              </a:defRPr>
+            </a:pPr>
+            <a:r>
+              <a:t>✓ Built-in Speak Aloud reader, Double Doctor Dialing button, and one-tap SOS Emergency modal.</a:t>
+            </a:r>
+          </a:p>
+          <a:p>
+            <a:pPr>
+              <a:spcAft>
+                <a:spcPts val="1000"/>
+              </a:spcAft>
+              <a:defRPr sz="1500">
+                <a:solidFill>
+                  <a:srgbClr val="FFFFFF"/>
+                </a:solidFill>
+                <a:latin typeface="Plus Jakarta Sans"/>
+              </a:defRPr>
+            </a:pPr>
+            <a:r>
+              <a:t>✓ Dynamic localization translating state checklists fully in Telugu and Hindi.</a:t>
+            </a:r>
+          </a:p>
+        </p:txBody>
+      </p:sp>
     </p:spTree>
   </p:cSld>
   <p:clrMapOvr>
@@ -3827,7 +3894,7 @@
               </a:defRPr>
             </a:pPr>
             <a:r>
-              <a:t>Tactile Medication Reminders</a:t>
+              <a:t>4. Hardware and Software Requirements</a:t>
             </a:r>
           </a:p>
         </p:txBody>
@@ -3841,7 +3908,7 @@
         <p:spPr>
           <a:xfrm>
             <a:off x="914400" y="1645920"/>
-            <a:ext cx="5486400" cy="4572000"/>
+            <a:ext cx="4754880" cy="4572000"/>
           </a:xfrm>
           <a:prstGeom prst="rect">
             <a:avLst/>
@@ -3855,10 +3922,10 @@
           <a:lstStyle/>
           <a:p>
             <a:pPr>
-              <a:spcBef>
-                <a:spcPts val="1000"/>
-              </a:spcBef>
-              <a:defRPr sz="1800" b="1">
+              <a:spcAft>
+                <a:spcPts val="1500"/>
+              </a:spcAft>
+              <a:defRPr sz="2200" b="1">
                 <a:solidFill>
                   <a:srgbClr val="0D9488"/>
                 </a:solidFill>
@@ -3866,7 +3933,7 @@
               </a:defRPr>
             </a:pPr>
             <a:r>
-              <a:t>• Overlay Alarm Modal</a:t>
+              <a:t>Hardware Requirements</a:t>
             </a:r>
           </a:p>
           <a:p>
@@ -3874,7 +3941,7 @@
               <a:spcAft>
                 <a:spcPts val="1000"/>
               </a:spcAft>
-              <a:defRPr sz="1500">
+              <a:defRPr sz="1600">
                 <a:solidFill>
                   <a:srgbClr val="FFFFFF"/>
                 </a:solidFill>
@@ -3882,23 +3949,7 @@
               </a:defRPr>
             </a:pPr>
             <a:r>
-              <a:t>   Due alerts overlay the dashboard instantly. Clearly highlights medication name, type, and specific dosage values.</a:t>
-            </a:r>
-          </a:p>
-          <a:p>
-            <a:pPr>
-              <a:spcBef>
-                <a:spcPts val="1000"/>
-              </a:spcBef>
-              <a:defRPr sz="1800" b="1">
-                <a:solidFill>
-                  <a:srgbClr val="0D9488"/>
-                </a:solidFill>
-                <a:latin typeface="Outfit"/>
-              </a:defRPr>
-            </a:pPr>
-            <a:r>
-              <a:t>• Direct Calling &amp; Snooze</a:t>
+              <a:t>• Patient / Caretaker Device: Mobile, Tablet, Laptop, or PC.</a:t>
             </a:r>
           </a:p>
           <a:p>
@@ -3906,7 +3957,7 @@
               <a:spcAft>
                 <a:spcPts val="1000"/>
               </a:spcAft>
-              <a:defRPr sz="1500">
+              <a:defRPr sz="1600">
                 <a:solidFill>
                   <a:srgbClr val="FFFFFF"/>
                 </a:solidFill>
@@ -3914,23 +3965,7 @@
               </a:defRPr>
             </a:pPr>
             <a:r>
-              <a:t>   Provides call doctor buttons alongside quick 10-minute snooze actions to prevent critical missed pills.</a:t>
-            </a:r>
-          </a:p>
-          <a:p>
-            <a:pPr>
-              <a:spcBef>
-                <a:spcPts val="1000"/>
-              </a:spcBef>
-              <a:defRPr sz="1800" b="1">
-                <a:solidFill>
-                  <a:srgbClr val="0D9488"/>
-                </a:solidFill>
-                <a:latin typeface="Outfit"/>
-              </a:defRPr>
-            </a:pPr>
-            <a:r>
-              <a:t>• Snappy Interaction Speed</a:t>
+              <a:t>• Processor: Intel Core i3 or similar Mobile SoC.</a:t>
             </a:r>
           </a:p>
           <a:p>
@@ -3938,7 +3973,7 @@
               <a:spcAft>
                 <a:spcPts val="1000"/>
               </a:spcAft>
-              <a:defRPr sz="1500">
+              <a:defRPr sz="1600">
                 <a:solidFill>
                   <a:srgbClr val="FFFFFF"/>
                 </a:solidFill>
@@ -3946,35 +3981,162 @@
               </a:defRPr>
             </a:pPr>
             <a:r>
-              <a:t>   0.05s touch feedback active scales and 100ms modal transition animations ensure buttons respond immediately on tap.</a:t>
-            </a:r>
-          </a:p>
-        </p:txBody>
-      </p:sp>
-      <p:pic>
-        <p:nvPicPr>
-          <p:cNvPr id="4" name="Picture 3" descr="dose_due.png"/>
-          <p:cNvPicPr>
-            <a:picLocks noChangeAspect="1"/>
-          </p:cNvPicPr>
+              <a:t>• RAM: 2 GB minimum (4 GB recommended).</a:t>
+            </a:r>
+          </a:p>
+          <a:p>
+            <a:pPr>
+              <a:spcAft>
+                <a:spcPts val="1000"/>
+              </a:spcAft>
+              <a:defRPr sz="1600">
+                <a:solidFill>
+                  <a:srgbClr val="FFFFFF"/>
+                </a:solidFill>
+                <a:latin typeface="Plus Jakarta Sans"/>
+              </a:defRPr>
+            </a:pPr>
+            <a:r>
+              <a:t>• Storage: 100 MB available local disk storage.</a:t>
+            </a:r>
+          </a:p>
+          <a:p>
+            <a:pPr>
+              <a:spcAft>
+                <a:spcPts val="1000"/>
+              </a:spcAft>
+              <a:defRPr sz="1600">
+                <a:solidFill>
+                  <a:srgbClr val="FFFFFF"/>
+                </a:solidFill>
+                <a:latin typeface="Plus Jakarta Sans"/>
+              </a:defRPr>
+            </a:pPr>
+            <a:r>
+              <a:t>• Display: Touchscreen display (for mobile usability).</a:t>
+            </a:r>
+          </a:p>
+        </p:txBody>
+      </p:sp>
+      <p:sp>
+        <p:nvSpPr>
+          <p:cNvPr id="4" name="TextBox 3"/>
+          <p:cNvSpPr txBox="1"/>
           <p:nvPr/>
-        </p:nvPicPr>
-        <p:blipFill>
-          <a:blip r:embed="rId2"/>
-          <a:stretch>
-            <a:fillRect/>
-          </a:stretch>
-        </p:blipFill>
+        </p:nvSpPr>
         <p:spPr>
           <a:xfrm>
-            <a:off x="6858000" y="1645920"/>
-            <a:ext cx="4389120" cy="3886200"/>
+            <a:off x="6400800" y="1645920"/>
+            <a:ext cx="4846320" cy="4572000"/>
           </a:xfrm>
           <a:prstGeom prst="rect">
             <a:avLst/>
           </a:prstGeom>
+          <a:noFill/>
         </p:spPr>
-      </p:pic>
+        <p:txBody>
+          <a:bodyPr wrap="square">
+            <a:spAutoFit/>
+          </a:bodyPr>
+          <a:lstStyle/>
+          <a:p>
+            <a:pPr>
+              <a:spcAft>
+                <a:spcPts val="1500"/>
+              </a:spcAft>
+              <a:defRPr sz="2200" b="1">
+                <a:solidFill>
+                  <a:srgbClr val="0D9488"/>
+                </a:solidFill>
+                <a:latin typeface="Outfit"/>
+              </a:defRPr>
+            </a:pPr>
+            <a:r>
+              <a:t>Software Requirements</a:t>
+            </a:r>
+          </a:p>
+          <a:p>
+            <a:pPr>
+              <a:spcAft>
+                <a:spcPts val="1000"/>
+              </a:spcAft>
+              <a:defRPr sz="1600">
+                <a:solidFill>
+                  <a:srgbClr val="FFFFFF"/>
+                </a:solidFill>
+                <a:latin typeface="Plus Jakarta Sans"/>
+              </a:defRPr>
+            </a:pPr>
+            <a:r>
+              <a:t>• Operating System: Windows 10/11, macOS, Android, or iOS.</a:t>
+            </a:r>
+          </a:p>
+          <a:p>
+            <a:pPr>
+              <a:spcAft>
+                <a:spcPts val="1000"/>
+              </a:spcAft>
+              <a:defRPr sz="1600">
+                <a:solidFill>
+                  <a:srgbClr val="FFFFFF"/>
+                </a:solidFill>
+                <a:latin typeface="Plus Jakarta Sans"/>
+              </a:defRPr>
+            </a:pPr>
+            <a:r>
+              <a:t>• Web Browser: Google Chrome, Safari, Firefox, or Microsoft Edge.</a:t>
+            </a:r>
+          </a:p>
+          <a:p>
+            <a:pPr>
+              <a:spcAft>
+                <a:spcPts val="1000"/>
+              </a:spcAft>
+              <a:defRPr sz="1600">
+                <a:solidFill>
+                  <a:srgbClr val="FFFFFF"/>
+                </a:solidFill>
+                <a:latin typeface="Plus Jakarta Sans"/>
+              </a:defRPr>
+            </a:pPr>
+            <a:r>
+              <a:t>• Development Stack: HTML5, CSS3 (Vanilla), ES6+ Javascript.</a:t>
+            </a:r>
+          </a:p>
+          <a:p>
+            <a:pPr>
+              <a:spcAft>
+                <a:spcPts val="1000"/>
+              </a:spcAft>
+              <a:defRPr sz="1600">
+                <a:solidFill>
+                  <a:srgbClr val="FFFFFF"/>
+                </a:solidFill>
+                <a:latin typeface="Plus Jakarta Sans"/>
+              </a:defRPr>
+            </a:pPr>
+            <a:r>
+              <a:t>• Database Layer: Cloud Firestore &amp; Local browser IndexedDB.</a:t>
+            </a:r>
+          </a:p>
+          <a:p>
+            <a:pPr>
+              <a:spcAft>
+                <a:spcPts val="1000"/>
+              </a:spcAft>
+              <a:defRPr sz="1600">
+                <a:solidFill>
+                  <a:srgbClr val="FFFFFF"/>
+                </a:solidFill>
+                <a:latin typeface="Plus Jakarta Sans"/>
+              </a:defRPr>
+            </a:pPr>
+            <a:r>
+              <a:t>• Hosting Environment: Vercel Production Server.</a:t>
+            </a:r>
+          </a:p>
+        </p:txBody>
+      </p:sp>
     </p:spTree>
   </p:cSld>
   <p:clrMapOvr>
@@ -4032,7 +4194,7 @@
               </a:defRPr>
             </a:pPr>
             <a:r>
-              <a:t>SOS Emergency Alert System</a:t>
+              <a:t>5. System Architecture</a:t>
             </a:r>
           </a:p>
         </p:txBody>
@@ -4046,7 +4208,7 @@
         <p:spPr>
           <a:xfrm>
             <a:off x="914400" y="1645920"/>
-            <a:ext cx="5486400" cy="4572000"/>
+            <a:ext cx="10360152" cy="4572000"/>
           </a:xfrm>
           <a:prstGeom prst="rect">
             <a:avLst/>
@@ -4060,8 +4222,24 @@
           <a:lstStyle/>
           <a:p>
             <a:pPr>
+              <a:spcAft>
+                <a:spcPts val="2000"/>
+              </a:spcAft>
+              <a:defRPr sz="1800">
+                <a:solidFill>
+                  <a:srgbClr val="9CA3AF"/>
+                </a:solidFill>
+                <a:latin typeface="Plus Jakarta Sans"/>
+              </a:defRPr>
+            </a:pPr>
+            <a:r>
+              <a:t>The platform implements a client-side architecture backed by background database synchronization modules:</a:t>
+            </a:r>
+          </a:p>
+          <a:p>
+            <a:pPr>
               <a:spcBef>
-                <a:spcPts val="1000"/>
+                <a:spcPts val="800"/>
               </a:spcBef>
               <a:defRPr sz="1800" b="1">
                 <a:solidFill>
@@ -4071,14 +4249,11 @@
               </a:defRPr>
             </a:pPr>
             <a:r>
-              <a:t>• Instant Alarm Sound</a:t>
-            </a:r>
-          </a:p>
-          <a:p>
-            <a:pPr>
-              <a:spcAft>
-                <a:spcPts val="1000"/>
-              </a:spcAft>
+              <a:t>1. User Interface Layer (HTML5/CSS3)</a:t>
+            </a:r>
+          </a:p>
+          <a:p>
+            <a:pPr>
               <a:defRPr sz="1500">
                 <a:solidFill>
                   <a:srgbClr val="FFFFFF"/>
@@ -4087,13 +4262,13 @@
               </a:defRPr>
             </a:pPr>
             <a:r>
-              <a:t>   SOS triggers local sirens, warns caregivers, and pops up the high-volume active emergency dashboard.</a:t>
+              <a:t>   Captures direct tap events, displays checklists, handles language changes, and animates alarms in 100ms.</a:t>
             </a:r>
           </a:p>
           <a:p>
             <a:pPr>
               <a:spcBef>
-                <a:spcPts val="1000"/>
+                <a:spcPts val="800"/>
               </a:spcBef>
               <a:defRPr sz="1800" b="1">
                 <a:solidFill>
@@ -4103,14 +4278,11 @@
               </a:defRPr>
             </a:pPr>
             <a:r>
-              <a:t>• One-Tap Doctor &amp; Caregiver Dials</a:t>
-            </a:r>
-          </a:p>
-          <a:p>
-            <a:pPr>
-              <a:spcAft>
-                <a:spcPts val="1000"/>
-              </a:spcAft>
+              <a:t>2. Local Persistence Store (IndexedDB Cache)</a:t>
+            </a:r>
+          </a:p>
+          <a:p>
+            <a:pPr>
               <a:defRPr sz="1500">
                 <a:solidFill>
                   <a:srgbClr val="FFFFFF"/>
@@ -4119,13 +4291,13 @@
               </a:defRPr>
             </a:pPr>
             <a:r>
-              <a:t>   Lists primary caregiver, doctor, and public helplines (108 / 112) with click-to-dial links.</a:t>
+              <a:t>   Maintains offline copy of user state. Reads and writes update here immediately, preventing thread blockages.</a:t>
             </a:r>
           </a:p>
           <a:p>
             <a:pPr>
               <a:spcBef>
-                <a:spcPts val="1000"/>
+                <a:spcPts val="800"/>
               </a:spcBef>
               <a:defRPr sz="1800" b="1">
                 <a:solidFill>
@@ -4135,14 +4307,11 @@
               </a:defRPr>
             </a:pPr>
             <a:r>
-              <a:t>• Safe Deactivation Action</a:t>
-            </a:r>
-          </a:p>
-          <a:p>
-            <a:pPr>
-              <a:spcAft>
-                <a:spcPts val="1000"/>
-              </a:spcAft>
+              <a:t>3. Cloud Sync Manager (Firestore Engine)</a:t>
+            </a:r>
+          </a:p>
+          <a:p>
+            <a:pPr>
               <a:defRPr sz="1500">
                 <a:solidFill>
                   <a:srgbClr val="FFFFFF"/>
@@ -4151,35 +4320,40 @@
               </a:defRPr>
             </a:pPr>
             <a:r>
-              <a:t>   Bold 'Stop Alarm &amp; Deactivate' button gives patients a fast path to dismiss alerts once safe.</a:t>
-            </a:r>
-          </a:p>
-        </p:txBody>
-      </p:sp>
-      <p:pic>
-        <p:nvPicPr>
-          <p:cNvPr id="4" name="Picture 3" descr="sos_alert.png"/>
-          <p:cNvPicPr>
-            <a:picLocks noChangeAspect="1"/>
-          </p:cNvPicPr>
-          <p:nvPr/>
-        </p:nvPicPr>
-        <p:blipFill>
-          <a:blip r:embed="rId2"/>
-          <a:stretch>
-            <a:fillRect/>
-          </a:stretch>
-        </p:blipFill>
-        <p:spPr>
-          <a:xfrm>
-            <a:off x="6858000" y="1645920"/>
-            <a:ext cx="4389120" cy="3886200"/>
-          </a:xfrm>
-          <a:prstGeom prst="rect">
-            <a:avLst/>
-          </a:prstGeom>
-        </p:spPr>
-      </p:pic>
+              <a:t>   Handles credentials, caregiver monitoring updates, and state syncing. Automatically falls back to local storage if network fails.</a:t>
+            </a:r>
+          </a:p>
+          <a:p>
+            <a:pPr>
+              <a:spcBef>
+                <a:spcPts val="800"/>
+              </a:spcBef>
+              <a:defRPr sz="1800" b="1">
+                <a:solidFill>
+                  <a:srgbClr val="0D9488"/>
+                </a:solidFill>
+                <a:latin typeface="Outfit"/>
+              </a:defRPr>
+            </a:pPr>
+            <a:r>
+              <a:t>4. Caregiver Live Grid</a:t>
+            </a:r>
+          </a:p>
+          <a:p>
+            <a:pPr>
+              <a:defRPr sz="1500">
+                <a:solidFill>
+                  <a:srgbClr val="FFFFFF"/>
+                </a:solidFill>
+                <a:latin typeface="Plus Jakarta Sans"/>
+              </a:defRPr>
+            </a:pPr>
+            <a:r>
+              <a:t>   Listens dynamically to states updates to output compliance metrics, streaks, and check-up notifications.</a:t>
+            </a:r>
+          </a:p>
+        </p:txBody>
+      </p:sp>
     </p:spTree>
   </p:cSld>
   <p:clrMapOvr>
@@ -4237,7 +4411,7 @@
               </a:defRPr>
             </a:pPr>
             <a:r>
-              <a:t>Technical Highlights &amp; Performance</a:t>
+              <a:t>6. Front End Design</a:t>
             </a:r>
           </a:p>
         </p:txBody>
@@ -4250,8 +4424,8 @@
         </p:nvSpPr>
         <p:spPr>
           <a:xfrm>
-            <a:off x="914400" y="1645920"/>
-            <a:ext cx="10360152" cy="4572000"/>
+            <a:off x="914400" y="1188720"/>
+            <a:ext cx="10360152" cy="548640"/>
           </a:xfrm>
           <a:prstGeom prst="rect">
             <a:avLst/>
@@ -4263,13 +4437,69 @@
             <a:spAutoFit/>
           </a:bodyPr>
           <a:lstStyle/>
-          <a:p/>
-          <a:p>
-            <a:pPr>
-              <a:spcBef>
-                <a:spcPts val="1200"/>
-              </a:spcBef>
-              <a:defRPr sz="2000" b="1">
+          <a:p>
+            <a:pPr>
+              <a:defRPr sz="1600">
+                <a:solidFill>
+                  <a:srgbClr val="9CA3AF"/>
+                </a:solidFill>
+                <a:latin typeface="Plus Jakarta Sans"/>
+              </a:defRPr>
+            </a:pPr>
+            <a:r>
+              <a:t>The user interface utilizes a responsive card layout with direct dialing, alarm overlays, and siren alerts:</a:t>
+            </a:r>
+          </a:p>
+        </p:txBody>
+      </p:sp>
+      <p:pic>
+        <p:nvPicPr>
+          <p:cNvPr id="4" name="Picture 3" descr="splash_screen.png"/>
+          <p:cNvPicPr>
+            <a:picLocks noChangeAspect="1"/>
+          </p:cNvPicPr>
+          <p:nvPr/>
+        </p:nvPicPr>
+        <p:blipFill>
+          <a:blip r:embed="rId2"/>
+          <a:stretch>
+            <a:fillRect/>
+          </a:stretch>
+        </p:blipFill>
+        <p:spPr>
+          <a:xfrm>
+            <a:off x="1097280" y="1828800"/>
+            <a:ext cx="2011680" cy="4023360"/>
+          </a:xfrm>
+          <a:prstGeom prst="rect">
+            <a:avLst/>
+          </a:prstGeom>
+        </p:spPr>
+      </p:pic>
+      <p:sp>
+        <p:nvSpPr>
+          <p:cNvPr id="5" name="TextBox 4"/>
+          <p:cNvSpPr txBox="1"/>
+          <p:nvPr/>
+        </p:nvSpPr>
+        <p:spPr>
+          <a:xfrm>
+            <a:off x="1097280" y="5989320"/>
+            <a:ext cx="2011680" cy="365760"/>
+          </a:xfrm>
+          <a:prstGeom prst="rect">
+            <a:avLst/>
+          </a:prstGeom>
+          <a:noFill/>
+        </p:spPr>
+        <p:txBody>
+          <a:bodyPr wrap="square">
+            <a:spAutoFit/>
+          </a:bodyPr>
+          <a:lstStyle/>
+          <a:p>
+            <a:pPr algn="ctr">
+              <a:defRPr sz="1300" b="1">
                 <a:solidFill>
                   <a:srgbClr val="0D9488"/>
                 </a:solidFill>
@@ -4277,31 +4507,59 @@
               </a:defRPr>
             </a:pPr>
             <a:r>
-              <a:t>• Firestore Offline Persistence</a:t>
-            </a:r>
-          </a:p>
-          <a:p>
-            <a:pPr>
-              <a:spcAft>
-                <a:spcPts val="1200"/>
-              </a:spcAft>
-              <a:defRPr sz="1600">
-                <a:solidFill>
-                  <a:srgbClr val="FFFFFF"/>
-                </a:solidFill>
-                <a:latin typeface="Plus Jakarta Sans"/>
-              </a:defRPr>
-            </a:pPr>
-            <a:r>
-              <a:t>   Configured IndexedDB tab synchronization on initialization. Writes are cached locally instantly, removing database write lags.</a:t>
-            </a:r>
-          </a:p>
-          <a:p>
-            <a:pPr>
-              <a:spcBef>
-                <a:spcPts val="1200"/>
-              </a:spcBef>
-              <a:defRPr sz="2000" b="1">
+              <a:t>Splash Screen</a:t>
+            </a:r>
+          </a:p>
+        </p:txBody>
+      </p:sp>
+      <p:pic>
+        <p:nvPicPr>
+          <p:cNvPr id="6" name="Picture 5" descr="dose_due.png"/>
+          <p:cNvPicPr>
+            <a:picLocks noChangeAspect="1"/>
+          </p:cNvPicPr>
+          <p:nvPr/>
+        </p:nvPicPr>
+        <p:blipFill>
+          <a:blip r:embed="rId3"/>
+          <a:stretch>
+            <a:fillRect/>
+          </a:stretch>
+        </p:blipFill>
+        <p:spPr>
+          <a:xfrm>
+            <a:off x="4389120" y="2286000"/>
+            <a:ext cx="3474720" cy="3108960"/>
+          </a:xfrm>
+          <a:prstGeom prst="rect">
+            <a:avLst/>
+          </a:prstGeom>
+        </p:spPr>
+      </p:pic>
+      <p:sp>
+        <p:nvSpPr>
+          <p:cNvPr id="7" name="TextBox 6"/>
+          <p:cNvSpPr txBox="1"/>
+          <p:nvPr/>
+        </p:nvSpPr>
+        <p:spPr>
+          <a:xfrm>
+            <a:off x="4389120" y="5532120"/>
+            <a:ext cx="3474720" cy="365760"/>
+          </a:xfrm>
+          <a:prstGeom prst="rect">
+            <a:avLst/>
+          </a:prstGeom>
+          <a:noFill/>
+        </p:spPr>
+        <p:txBody>
+          <a:bodyPr wrap="square">
+            <a:spAutoFit/>
+          </a:bodyPr>
+          <a:lstStyle/>
+          <a:p>
+            <a:pPr algn="ctr">
+              <a:defRPr sz="1300" b="1">
                 <a:solidFill>
                   <a:srgbClr val="0D9488"/>
                 </a:solidFill>
@@ -4309,31 +4567,59 @@
               </a:defRPr>
             </a:pPr>
             <a:r>
-              <a:t>• Zero Click Latency</a:t>
-            </a:r>
-          </a:p>
-          <a:p>
-            <a:pPr>
-              <a:spcAft>
-                <a:spcPts val="1200"/>
-              </a:spcAft>
-              <a:defRPr sz="1600">
-                <a:solidFill>
-                  <a:srgbClr val="FFFFFF"/>
-                </a:solidFill>
-                <a:latin typeface="Plus Jakarta Sans"/>
-              </a:defRPr>
-            </a:pPr>
-            <a:r>
-              <a:t>   Added touch-action CSS manipulation overrides to remove 300ms mobile tap delay, and 50ms active button scaling shrink effects.</a:t>
-            </a:r>
-          </a:p>
-          <a:p>
-            <a:pPr>
-              <a:spcBef>
-                <a:spcPts val="1200"/>
-              </a:spcBef>
-              <a:defRPr sz="2000" b="1">
+              <a:t>Dose Due Alert Overlay</a:t>
+            </a:r>
+          </a:p>
+        </p:txBody>
+      </p:sp>
+      <p:pic>
+        <p:nvPicPr>
+          <p:cNvPr id="8" name="Picture 7" descr="sos_alert.png"/>
+          <p:cNvPicPr>
+            <a:picLocks noChangeAspect="1"/>
+          </p:cNvPicPr>
+          <p:nvPr/>
+        </p:nvPicPr>
+        <p:blipFill>
+          <a:blip r:embed="rId4"/>
+          <a:stretch>
+            <a:fillRect/>
+          </a:stretch>
+        </p:blipFill>
+        <p:spPr>
+          <a:xfrm>
+            <a:off x="8229600" y="2286000"/>
+            <a:ext cx="3474720" cy="3108960"/>
+          </a:xfrm>
+          <a:prstGeom prst="rect">
+            <a:avLst/>
+          </a:prstGeom>
+        </p:spPr>
+      </p:pic>
+      <p:sp>
+        <p:nvSpPr>
+          <p:cNvPr id="9" name="TextBox 8"/>
+          <p:cNvSpPr txBox="1"/>
+          <p:nvPr/>
+        </p:nvSpPr>
+        <p:spPr>
+          <a:xfrm>
+            <a:off x="8229600" y="5532120"/>
+            <a:ext cx="3474720" cy="365760"/>
+          </a:xfrm>
+          <a:prstGeom prst="rect">
+            <a:avLst/>
+          </a:prstGeom>
+          <a:noFill/>
+        </p:spPr>
+        <p:txBody>
+          <a:bodyPr wrap="square">
+            <a:spAutoFit/>
+          </a:bodyPr>
+          <a:lstStyle/>
+          <a:p>
+            <a:pPr algn="ctr">
+              <a:defRPr sz="1300" b="1">
                 <a:solidFill>
                   <a:srgbClr val="0D9488"/>
                 </a:solidFill>
@@ -4341,23 +4627,7 @@
               </a:defRPr>
             </a:pPr>
             <a:r>
-              <a:t>• Graceful Local Caching &amp; Fallbacks</a:t>
-            </a:r>
-          </a:p>
-          <a:p>
-            <a:pPr>
-              <a:spcAft>
-                <a:spcPts val="1200"/>
-              </a:spcAft>
-              <a:defRPr sz="1600">
-                <a:solidFill>
-                  <a:srgbClr val="FFFFFF"/>
-                </a:solidFill>
-                <a:latin typeface="Plus Jakarta Sans"/>
-              </a:defRPr>
-            </a:pPr>
-            <a:r>
-              <a:t>   Any API error or permissions failure falls back automatically to local database storage to guarantee 100% uptime.</a:t>
+              <a:t>Emergency SOS Modal</a:t>
             </a:r>
           </a:p>
         </p:txBody>
@@ -4419,7 +4689,7 @@
               </a:defRPr>
             </a:pPr>
             <a:r>
-              <a:t>Making Healthcare Simple, Reliable &amp; Snap-Fast</a:t>
+              <a:t>Healthcare Adherence Re-imagined</a:t>
             </a:r>
           </a:p>
           <a:p>
@@ -4427,7 +4697,7 @@
               <a:spcBef>
                 <a:spcPts val="1500"/>
               </a:spcBef>
-              <a:defRPr sz="2200" b="1">
+              <a:defRPr sz="2000" b="1">
                 <a:solidFill>
                   <a:srgbClr val="FFFFFF"/>
                 </a:solidFill>
@@ -4435,7 +4705,7 @@
               </a:defRPr>
             </a:pPr>
             <a:r>
-              <a:t>Medicare Reminder System</a:t>
+              <a:t>Offline-First, Zero click latency, and Immediate Caretaker SOS Alerts</a:t>
             </a:r>
           </a:p>
           <a:p>
@@ -4443,7 +4713,7 @@
               <a:spcBef>
                 <a:spcPts val="1000"/>
               </a:spcBef>
-              <a:defRPr sz="1800">
+              <a:defRPr sz="1600">
                 <a:solidFill>
                   <a:srgbClr val="9CA3AF"/>
                 </a:solidFill>
@@ -4451,7 +4721,7 @@
               </a:defRPr>
             </a:pPr>
             <a:r>
-              <a:t>Live App URL: medicine-reminder-navy-phi.vercel.app</a:t>
+              <a:t>Live Deployment: medicine-reminder-navy-phi.vercel.app</a:t>
             </a:r>
           </a:p>
         </p:txBody>

</xml_diff>

<commit_message>
docs: separate frontend design screenshots into individual slides (10 slides total)
</commit_message>
<xml_diff>
--- a/medicare_presentation.pptx
+++ b/medicare_presentation.pptx
@@ -13,6 +13,8 @@
     <p:sldId id="261" r:id="rId12"/>
     <p:sldId id="262" r:id="rId13"/>
     <p:sldId id="263" r:id="rId14"/>
+    <p:sldId id="264" r:id="rId15"/>
+    <p:sldId id="265" r:id="rId16"/>
   </p:sldIdLst>
   <p:sldSz cx="12188952" cy="6858000" type="screen4x3"/>
   <p:notesSz cx="6858000" cy="9144000"/>
@@ -3179,6 +3181,100 @@
 </p:sld>
 </file>
 
+<file path=ppt/slides/slide10.xml><?xml version="1.0" encoding="utf-8"?>
+<p:sld xmlns:a="http://schemas.openxmlformats.org/drawingml/2006/main" xmlns:p="http://schemas.openxmlformats.org/presentationml/2006/main" xmlns:r="http://schemas.openxmlformats.org/officeDocument/2006/relationships">
+  <p:cSld>
+    <p:bg>
+      <p:bgPr>
+        <a:solidFill>
+          <a:srgbClr val="090D16"/>
+        </a:solidFill>
+        <a:effectLst/>
+      </p:bgPr>
+    </p:bg>
+    <p:spTree>
+      <p:nvGrpSpPr>
+        <p:cNvPr id="1" name=""/>
+        <p:cNvGrpSpPr/>
+        <p:nvPr/>
+      </p:nvGrpSpPr>
+      <p:grpSpPr/>
+      <p:sp>
+        <p:nvSpPr>
+          <p:cNvPr id="2" name="TextBox 1"/>
+          <p:cNvSpPr txBox="1"/>
+          <p:nvPr/>
+        </p:nvSpPr>
+        <p:spPr>
+          <a:xfrm>
+            <a:off x="914400" y="2011680"/>
+            <a:ext cx="10360152" cy="3200400"/>
+          </a:xfrm>
+          <a:prstGeom prst="rect">
+            <a:avLst/>
+          </a:prstGeom>
+          <a:noFill/>
+        </p:spPr>
+        <p:txBody>
+          <a:bodyPr wrap="square">
+            <a:spAutoFit/>
+          </a:bodyPr>
+          <a:lstStyle/>
+          <a:p>
+            <a:pPr algn="ctr">
+              <a:defRPr sz="3600" b="1">
+                <a:solidFill>
+                  <a:srgbClr val="0D9488"/>
+                </a:solidFill>
+                <a:latin typeface="Outfit"/>
+              </a:defRPr>
+            </a:pPr>
+            <a:r>
+              <a:t>Healthcare Adherence Re-imagined</a:t>
+            </a:r>
+          </a:p>
+          <a:p>
+            <a:pPr algn="ctr">
+              <a:spcBef>
+                <a:spcPts val="1500"/>
+              </a:spcBef>
+              <a:defRPr sz="2000" b="1">
+                <a:solidFill>
+                  <a:srgbClr val="FFFFFF"/>
+                </a:solidFill>
+                <a:latin typeface="Plus Jakarta Sans"/>
+              </a:defRPr>
+            </a:pPr>
+            <a:r>
+              <a:t>Offline-First, Zero click latency, and Immediate Caretaker SOS Alerts</a:t>
+            </a:r>
+          </a:p>
+          <a:p>
+            <a:pPr algn="ctr">
+              <a:spcBef>
+                <a:spcPts val="1000"/>
+              </a:spcBef>
+              <a:defRPr sz="1600">
+                <a:solidFill>
+                  <a:srgbClr val="9CA3AF"/>
+                </a:solidFill>
+                <a:latin typeface="Plus Jakarta Sans"/>
+              </a:defRPr>
+            </a:pPr>
+            <a:r>
+              <a:t>Live Deployment: medicine-reminder-navy-phi.vercel.app</a:t>
+            </a:r>
+          </a:p>
+        </p:txBody>
+      </p:sp>
+    </p:spTree>
+  </p:cSld>
+  <p:clrMapOvr>
+    <a:masterClrMapping/>
+  </p:clrMapOvr>
+</p:sld>
+</file>
+
 <file path=ppt/slides/slide2.xml><?xml version="1.0" encoding="utf-8"?>
 <p:sld xmlns:a="http://schemas.openxmlformats.org/drawingml/2006/main" xmlns:p="http://schemas.openxmlformats.org/presentationml/2006/main" xmlns:r="http://schemas.openxmlformats.org/officeDocument/2006/relationships">
   <p:cSld>
@@ -3729,7 +3825,7 @@
               </a:defRPr>
             </a:pPr>
             <a:r>
-              <a:t>• English-only platforms that pose barriers to rural or regional elderly users.</a:t>
+              <a:t>• English-only platforms that pose barriers to regional elderly users.</a:t>
             </a:r>
           </a:p>
         </p:txBody>
@@ -4233,7 +4329,7 @@
               </a:defRPr>
             </a:pPr>
             <a:r>
-              <a:t>The platform implements a client-side architecture backed by background database synchronization modules:</a:t>
+              <a:t>The platform separates interface events, caching operations, and database synchronization to ensure lag-free usability:</a:t>
             </a:r>
           </a:p>
           <a:p>
@@ -4411,7 +4507,7 @@
               </a:defRPr>
             </a:pPr>
             <a:r>
-              <a:t>6. Front End Design</a:t>
+              <a:t>6. Front End Design - Splash Screen</a:t>
             </a:r>
           </a:p>
         </p:txBody>
@@ -4424,8 +4520,8 @@
         </p:nvSpPr>
         <p:spPr>
           <a:xfrm>
-            <a:off x="914400" y="1188720"/>
-            <a:ext cx="10360152" cy="548640"/>
+            <a:off x="914400" y="1645920"/>
+            <a:ext cx="5486400" cy="4572000"/>
           </a:xfrm>
           <a:prstGeom prst="rect">
             <a:avLst/>
@@ -4439,15 +4535,98 @@
           <a:lstStyle/>
           <a:p>
             <a:pPr>
-              <a:defRPr sz="1600">
-                <a:solidFill>
-                  <a:srgbClr val="9CA3AF"/>
+              <a:spcBef>
+                <a:spcPts val="1000"/>
+              </a:spcBef>
+              <a:defRPr sz="1800" b="1">
+                <a:solidFill>
+                  <a:srgbClr val="0D9488"/>
+                </a:solidFill>
+                <a:latin typeface="Outfit"/>
+              </a:defRPr>
+            </a:pPr>
+            <a:r>
+              <a:t>• Modern Visual Style</a:t>
+            </a:r>
+          </a:p>
+          <a:p>
+            <a:pPr>
+              <a:spcAft>
+                <a:spcPts val="1000"/>
+              </a:spcAft>
+              <a:defRPr sz="1500">
+                <a:solidFill>
+                  <a:srgbClr val="FFFFFF"/>
                 </a:solidFill>
                 <a:latin typeface="Plus Jakarta Sans"/>
               </a:defRPr>
             </a:pPr>
             <a:r>
-              <a:t>The user interface utilizes a responsive card layout with direct dialing, alarm overlays, and siren alerts:</a:t>
+              <a:t>   Curated dark background with glowing accent colors matching patient and caregiver entry routes.</a:t>
+            </a:r>
+          </a:p>
+          <a:p>
+            <a:pPr>
+              <a:spcBef>
+                <a:spcPts val="1000"/>
+              </a:spcBef>
+              <a:defRPr sz="1800" b="1">
+                <a:solidFill>
+                  <a:srgbClr val="0D9488"/>
+                </a:solidFill>
+                <a:latin typeface="Outfit"/>
+              </a:defRPr>
+            </a:pPr>
+            <a:r>
+              <a:t>• Adaptive Branding Identity</a:t>
+            </a:r>
+          </a:p>
+          <a:p>
+            <a:pPr>
+              <a:spcAft>
+                <a:spcPts val="1000"/>
+              </a:spcAft>
+              <a:defRPr sz="1500">
+                <a:solidFill>
+                  <a:srgbClr val="FFFFFF"/>
+                </a:solidFill>
+                <a:latin typeface="Plus Jakarta Sans"/>
+              </a:defRPr>
+            </a:pPr>
+            <a:r>
+              <a:t>   Branding splash introducing 'Your Health, Our Priority' slogan within responsive mobile containers.</a:t>
+            </a:r>
+          </a:p>
+          <a:p>
+            <a:pPr>
+              <a:spcBef>
+                <a:spcPts val="1000"/>
+              </a:spcBef>
+              <a:defRPr sz="1800" b="1">
+                <a:solidFill>
+                  <a:srgbClr val="0D9488"/>
+                </a:solidFill>
+                <a:latin typeface="Outfit"/>
+              </a:defRPr>
+            </a:pPr>
+            <a:r>
+              <a:t>• Simple Selection Portals</a:t>
+            </a:r>
+          </a:p>
+          <a:p>
+            <a:pPr>
+              <a:spcAft>
+                <a:spcPts val="1000"/>
+              </a:spcAft>
+              <a:defRPr sz="1500">
+                <a:solidFill>
+                  <a:srgbClr val="FFFFFF"/>
+                </a:solidFill>
+                <a:latin typeface="Plus Jakarta Sans"/>
+              </a:defRPr>
+            </a:pPr>
+            <a:r>
+              <a:t>   Clean buttons letting patients log in or caretakers switch to status grids immediately.</a:t>
             </a:r>
           </a:p>
         </p:txBody>
@@ -4468,170 +4647,14 @@
         </p:blipFill>
         <p:spPr>
           <a:xfrm>
-            <a:off x="1097280" y="1828800"/>
-            <a:ext cx="2011680" cy="4023360"/>
+            <a:off x="7772400" y="1097280"/>
+            <a:ext cx="2286000" cy="4572000"/>
           </a:xfrm>
           <a:prstGeom prst="rect">
             <a:avLst/>
           </a:prstGeom>
         </p:spPr>
       </p:pic>
-      <p:sp>
-        <p:nvSpPr>
-          <p:cNvPr id="5" name="TextBox 4"/>
-          <p:cNvSpPr txBox="1"/>
-          <p:nvPr/>
-        </p:nvSpPr>
-        <p:spPr>
-          <a:xfrm>
-            <a:off x="1097280" y="5989320"/>
-            <a:ext cx="2011680" cy="365760"/>
-          </a:xfrm>
-          <a:prstGeom prst="rect">
-            <a:avLst/>
-          </a:prstGeom>
-          <a:noFill/>
-        </p:spPr>
-        <p:txBody>
-          <a:bodyPr wrap="square">
-            <a:spAutoFit/>
-          </a:bodyPr>
-          <a:lstStyle/>
-          <a:p>
-            <a:pPr algn="ctr">
-              <a:defRPr sz="1300" b="1">
-                <a:solidFill>
-                  <a:srgbClr val="0D9488"/>
-                </a:solidFill>
-                <a:latin typeface="Outfit"/>
-              </a:defRPr>
-            </a:pPr>
-            <a:r>
-              <a:t>Splash Screen</a:t>
-            </a:r>
-          </a:p>
-        </p:txBody>
-      </p:sp>
-      <p:pic>
-        <p:nvPicPr>
-          <p:cNvPr id="6" name="Picture 5" descr="dose_due.png"/>
-          <p:cNvPicPr>
-            <a:picLocks noChangeAspect="1"/>
-          </p:cNvPicPr>
-          <p:nvPr/>
-        </p:nvPicPr>
-        <p:blipFill>
-          <a:blip r:embed="rId3"/>
-          <a:stretch>
-            <a:fillRect/>
-          </a:stretch>
-        </p:blipFill>
-        <p:spPr>
-          <a:xfrm>
-            <a:off x="4389120" y="2286000"/>
-            <a:ext cx="3474720" cy="3108960"/>
-          </a:xfrm>
-          <a:prstGeom prst="rect">
-            <a:avLst/>
-          </a:prstGeom>
-        </p:spPr>
-      </p:pic>
-      <p:sp>
-        <p:nvSpPr>
-          <p:cNvPr id="7" name="TextBox 6"/>
-          <p:cNvSpPr txBox="1"/>
-          <p:nvPr/>
-        </p:nvSpPr>
-        <p:spPr>
-          <a:xfrm>
-            <a:off x="4389120" y="5532120"/>
-            <a:ext cx="3474720" cy="365760"/>
-          </a:xfrm>
-          <a:prstGeom prst="rect">
-            <a:avLst/>
-          </a:prstGeom>
-          <a:noFill/>
-        </p:spPr>
-        <p:txBody>
-          <a:bodyPr wrap="square">
-            <a:spAutoFit/>
-          </a:bodyPr>
-          <a:lstStyle/>
-          <a:p>
-            <a:pPr algn="ctr">
-              <a:defRPr sz="1300" b="1">
-                <a:solidFill>
-                  <a:srgbClr val="0D9488"/>
-                </a:solidFill>
-                <a:latin typeface="Outfit"/>
-              </a:defRPr>
-            </a:pPr>
-            <a:r>
-              <a:t>Dose Due Alert Overlay</a:t>
-            </a:r>
-          </a:p>
-        </p:txBody>
-      </p:sp>
-      <p:pic>
-        <p:nvPicPr>
-          <p:cNvPr id="8" name="Picture 7" descr="sos_alert.png"/>
-          <p:cNvPicPr>
-            <a:picLocks noChangeAspect="1"/>
-          </p:cNvPicPr>
-          <p:nvPr/>
-        </p:nvPicPr>
-        <p:blipFill>
-          <a:blip r:embed="rId4"/>
-          <a:stretch>
-            <a:fillRect/>
-          </a:stretch>
-        </p:blipFill>
-        <p:spPr>
-          <a:xfrm>
-            <a:off x="8229600" y="2286000"/>
-            <a:ext cx="3474720" cy="3108960"/>
-          </a:xfrm>
-          <a:prstGeom prst="rect">
-            <a:avLst/>
-          </a:prstGeom>
-        </p:spPr>
-      </p:pic>
-      <p:sp>
-        <p:nvSpPr>
-          <p:cNvPr id="9" name="TextBox 8"/>
-          <p:cNvSpPr txBox="1"/>
-          <p:nvPr/>
-        </p:nvSpPr>
-        <p:spPr>
-          <a:xfrm>
-            <a:off x="8229600" y="5532120"/>
-            <a:ext cx="3474720" cy="365760"/>
-          </a:xfrm>
-          <a:prstGeom prst="rect">
-            <a:avLst/>
-          </a:prstGeom>
-          <a:noFill/>
-        </p:spPr>
-        <p:txBody>
-          <a:bodyPr wrap="square">
-            <a:spAutoFit/>
-          </a:bodyPr>
-          <a:lstStyle/>
-          <a:p>
-            <a:pPr algn="ctr">
-              <a:defRPr sz="1300" b="1">
-                <a:solidFill>
-                  <a:srgbClr val="0D9488"/>
-                </a:solidFill>
-                <a:latin typeface="Outfit"/>
-              </a:defRPr>
-            </a:pPr>
-            <a:r>
-              <a:t>Emergency SOS Modal</a:t>
-            </a:r>
-          </a:p>
-        </p:txBody>
-      </p:sp>
     </p:spTree>
   </p:cSld>
   <p:clrMapOvr>
@@ -4666,8 +4689,8 @@
         </p:nvSpPr>
         <p:spPr>
           <a:xfrm>
-            <a:off x="914400" y="2011680"/>
-            <a:ext cx="10360152" cy="3200400"/>
+            <a:off x="914400" y="457200"/>
+            <a:ext cx="10360152" cy="731520"/>
           </a:xfrm>
           <a:prstGeom prst="rect">
             <a:avLst/>
@@ -4680,7 +4703,7 @@
           </a:bodyPr>
           <a:lstStyle/>
           <a:p>
-            <a:pPr algn="ctr">
+            <a:pPr>
               <a:defRPr sz="3600" b="1">
                 <a:solidFill>
                   <a:srgbClr val="0D9488"/>
@@ -4689,43 +4712,359 @@
               </a:defRPr>
             </a:pPr>
             <a:r>
-              <a:t>Healthcare Adherence Re-imagined</a:t>
-            </a:r>
-          </a:p>
-          <a:p>
-            <a:pPr algn="ctr">
-              <a:spcBef>
-                <a:spcPts val="1500"/>
-              </a:spcBef>
-              <a:defRPr sz="2000" b="1">
-                <a:solidFill>
-                  <a:srgbClr val="FFFFFF"/>
-                </a:solidFill>
-                <a:latin typeface="Plus Jakarta Sans"/>
-              </a:defRPr>
-            </a:pPr>
-            <a:r>
-              <a:t>Offline-First, Zero click latency, and Immediate Caretaker SOS Alerts</a:t>
-            </a:r>
-          </a:p>
-          <a:p>
-            <a:pPr algn="ctr">
+              <a:t>6. Front End Design - Dose Alert Modal</a:t>
+            </a:r>
+          </a:p>
+        </p:txBody>
+      </p:sp>
+      <p:sp>
+        <p:nvSpPr>
+          <p:cNvPr id="3" name="TextBox 2"/>
+          <p:cNvSpPr txBox="1"/>
+          <p:nvPr/>
+        </p:nvSpPr>
+        <p:spPr>
+          <a:xfrm>
+            <a:off x="914400" y="1645920"/>
+            <a:ext cx="5486400" cy="4572000"/>
+          </a:xfrm>
+          <a:prstGeom prst="rect">
+            <a:avLst/>
+          </a:prstGeom>
+          <a:noFill/>
+        </p:spPr>
+        <p:txBody>
+          <a:bodyPr wrap="square">
+            <a:spAutoFit/>
+          </a:bodyPr>
+          <a:lstStyle/>
+          <a:p>
+            <a:pPr>
               <a:spcBef>
                 <a:spcPts val="1000"/>
               </a:spcBef>
-              <a:defRPr sz="1600">
-                <a:solidFill>
-                  <a:srgbClr val="9CA3AF"/>
+              <a:defRPr sz="1800" b="1">
+                <a:solidFill>
+                  <a:srgbClr val="0D9488"/>
+                </a:solidFill>
+                <a:latin typeface="Outfit"/>
+              </a:defRPr>
+            </a:pPr>
+            <a:r>
+              <a:t>• Overlay Warning Panel</a:t>
+            </a:r>
+          </a:p>
+          <a:p>
+            <a:pPr>
+              <a:spcAft>
+                <a:spcPts val="1000"/>
+              </a:spcAft>
+              <a:defRPr sz="1500">
+                <a:solidFill>
+                  <a:srgbClr val="FFFFFF"/>
                 </a:solidFill>
                 <a:latin typeface="Plus Jakarta Sans"/>
               </a:defRPr>
             </a:pPr>
             <a:r>
-              <a:t>Live Deployment: medicine-reminder-navy-phi.vercel.app</a:t>
-            </a:r>
-          </a:p>
-        </p:txBody>
-      </p:sp>
+              <a:t>   Alarm due cards intercept the main workspace immediately. Shows bold title, category form, and timing logs.</a:t>
+            </a:r>
+          </a:p>
+          <a:p>
+            <a:pPr>
+              <a:spcBef>
+                <a:spcPts val="1000"/>
+              </a:spcBef>
+              <a:defRPr sz="1800" b="1">
+                <a:solidFill>
+                  <a:srgbClr val="0D9488"/>
+                </a:solidFill>
+                <a:latin typeface="Outfit"/>
+              </a:defRPr>
+            </a:pPr>
+            <a:r>
+              <a:t>• Quick Dials &amp; Skip Actions</a:t>
+            </a:r>
+          </a:p>
+          <a:p>
+            <a:pPr>
+              <a:spcAft>
+                <a:spcPts val="1000"/>
+              </a:spcAft>
+              <a:defRPr sz="1500">
+                <a:solidFill>
+                  <a:srgbClr val="FFFFFF"/>
+                </a:solidFill>
+                <a:latin typeface="Plus Jakarta Sans"/>
+              </a:defRPr>
+            </a:pPr>
+            <a:r>
+              <a:t>   Integrated Call Doctor buttons allow seniors to dial primary clinics with one simple tap.</a:t>
+            </a:r>
+          </a:p>
+          <a:p>
+            <a:pPr>
+              <a:spcBef>
+                <a:spcPts val="1000"/>
+              </a:spcBef>
+              <a:defRPr sz="1800" b="1">
+                <a:solidFill>
+                  <a:srgbClr val="0D9488"/>
+                </a:solidFill>
+                <a:latin typeface="Outfit"/>
+              </a:defRPr>
+            </a:pPr>
+            <a:r>
+              <a:t>• Snappy Interaction Speeds</a:t>
+            </a:r>
+          </a:p>
+          <a:p>
+            <a:pPr>
+              <a:spcAft>
+                <a:spcPts val="1000"/>
+              </a:spcAft>
+              <a:defRPr sz="1500">
+                <a:solidFill>
+                  <a:srgbClr val="FFFFFF"/>
+                </a:solidFill>
+                <a:latin typeface="Plus Jakarta Sans"/>
+              </a:defRPr>
+            </a:pPr>
+            <a:r>
+              <a:t>   0.05s touch feedbacks and 100ms popup openings ensure senior actions save immediately.</a:t>
+            </a:r>
+          </a:p>
+        </p:txBody>
+      </p:sp>
+      <p:pic>
+        <p:nvPicPr>
+          <p:cNvPr id="4" name="Picture 3" descr="dose_due.png"/>
+          <p:cNvPicPr>
+            <a:picLocks noChangeAspect="1"/>
+          </p:cNvPicPr>
+          <p:nvPr/>
+        </p:nvPicPr>
+        <p:blipFill>
+          <a:blip r:embed="rId2"/>
+          <a:stretch>
+            <a:fillRect/>
+          </a:stretch>
+        </p:blipFill>
+        <p:spPr>
+          <a:xfrm>
+            <a:off x="6858000" y="1645920"/>
+            <a:ext cx="4114800" cy="3657600"/>
+          </a:xfrm>
+          <a:prstGeom prst="rect">
+            <a:avLst/>
+          </a:prstGeom>
+        </p:spPr>
+      </p:pic>
+    </p:spTree>
+  </p:cSld>
+  <p:clrMapOvr>
+    <a:masterClrMapping/>
+  </p:clrMapOvr>
+</p:sld>
+</file>
+
+<file path=ppt/slides/slide9.xml><?xml version="1.0" encoding="utf-8"?>
+<p:sld xmlns:a="http://schemas.openxmlformats.org/drawingml/2006/main" xmlns:p="http://schemas.openxmlformats.org/presentationml/2006/main" xmlns:r="http://schemas.openxmlformats.org/officeDocument/2006/relationships">
+  <p:cSld>
+    <p:bg>
+      <p:bgPr>
+        <a:solidFill>
+          <a:srgbClr val="090D16"/>
+        </a:solidFill>
+        <a:effectLst/>
+      </p:bgPr>
+    </p:bg>
+    <p:spTree>
+      <p:nvGrpSpPr>
+        <p:cNvPr id="1" name=""/>
+        <p:cNvGrpSpPr/>
+        <p:nvPr/>
+      </p:nvGrpSpPr>
+      <p:grpSpPr/>
+      <p:sp>
+        <p:nvSpPr>
+          <p:cNvPr id="2" name="TextBox 1"/>
+          <p:cNvSpPr txBox="1"/>
+          <p:nvPr/>
+        </p:nvSpPr>
+        <p:spPr>
+          <a:xfrm>
+            <a:off x="914400" y="457200"/>
+            <a:ext cx="10360152" cy="731520"/>
+          </a:xfrm>
+          <a:prstGeom prst="rect">
+            <a:avLst/>
+          </a:prstGeom>
+          <a:noFill/>
+        </p:spPr>
+        <p:txBody>
+          <a:bodyPr wrap="square">
+            <a:spAutoFit/>
+          </a:bodyPr>
+          <a:lstStyle/>
+          <a:p>
+            <a:pPr>
+              <a:defRPr sz="3600" b="1">
+                <a:solidFill>
+                  <a:srgbClr val="0D9488"/>
+                </a:solidFill>
+                <a:latin typeface="Outfit"/>
+              </a:defRPr>
+            </a:pPr>
+            <a:r>
+              <a:t>6. Front End Design - SOS Emergency Alert</a:t>
+            </a:r>
+          </a:p>
+        </p:txBody>
+      </p:sp>
+      <p:sp>
+        <p:nvSpPr>
+          <p:cNvPr id="3" name="TextBox 2"/>
+          <p:cNvSpPr txBox="1"/>
+          <p:nvPr/>
+        </p:nvSpPr>
+        <p:spPr>
+          <a:xfrm>
+            <a:off x="914400" y="1645920"/>
+            <a:ext cx="5486400" cy="4572000"/>
+          </a:xfrm>
+          <a:prstGeom prst="rect">
+            <a:avLst/>
+          </a:prstGeom>
+          <a:noFill/>
+        </p:spPr>
+        <p:txBody>
+          <a:bodyPr wrap="square">
+            <a:spAutoFit/>
+          </a:bodyPr>
+          <a:lstStyle/>
+          <a:p>
+            <a:pPr>
+              <a:spcBef>
+                <a:spcPts val="1000"/>
+              </a:spcBef>
+              <a:defRPr sz="1800" b="1">
+                <a:solidFill>
+                  <a:srgbClr val="0D9488"/>
+                </a:solidFill>
+                <a:latin typeface="Outfit"/>
+              </a:defRPr>
+            </a:pPr>
+            <a:r>
+              <a:t>• Critical Warn siren Alert</a:t>
+            </a:r>
+          </a:p>
+          <a:p>
+            <a:pPr>
+              <a:spcAft>
+                <a:spcPts val="1000"/>
+              </a:spcAft>
+              <a:defRPr sz="1500">
+                <a:solidFill>
+                  <a:srgbClr val="FFFFFF"/>
+                </a:solidFill>
+                <a:latin typeface="Plus Jakarta Sans"/>
+              </a:defRPr>
+            </a:pPr>
+            <a:r>
+              <a:t>   One tap triggers emergency sirening, alerts caretakers, and opens active health alerts dashboard.</a:t>
+            </a:r>
+          </a:p>
+          <a:p>
+            <a:pPr>
+              <a:spcBef>
+                <a:spcPts val="1000"/>
+              </a:spcBef>
+              <a:defRPr sz="1800" b="1">
+                <a:solidFill>
+                  <a:srgbClr val="0D9488"/>
+                </a:solidFill>
+                <a:latin typeface="Outfit"/>
+              </a:defRPr>
+            </a:pPr>
+            <a:r>
+              <a:t>• Helper Public Contacts</a:t>
+            </a:r>
+          </a:p>
+          <a:p>
+            <a:pPr>
+              <a:spcAft>
+                <a:spcPts val="1000"/>
+              </a:spcAft>
+              <a:defRPr sz="1500">
+                <a:solidFill>
+                  <a:srgbClr val="FFFFFF"/>
+                </a:solidFill>
+                <a:latin typeface="Plus Jakarta Sans"/>
+              </a:defRPr>
+            </a:pPr>
+            <a:r>
+              <a:t>   Clearly visible links for direct dials to emergency contact numbers and medical helpline lines (108 / 112).</a:t>
+            </a:r>
+          </a:p>
+          <a:p>
+            <a:pPr>
+              <a:spcBef>
+                <a:spcPts val="1000"/>
+              </a:spcBef>
+              <a:defRPr sz="1800" b="1">
+                <a:solidFill>
+                  <a:srgbClr val="0D9488"/>
+                </a:solidFill>
+                <a:latin typeface="Outfit"/>
+              </a:defRPr>
+            </a:pPr>
+            <a:r>
+              <a:t>• Snap Deactivate Button</a:t>
+            </a:r>
+          </a:p>
+          <a:p>
+            <a:pPr>
+              <a:spcAft>
+                <a:spcPts val="1000"/>
+              </a:spcAft>
+              <a:defRPr sz="1500">
+                <a:solidFill>
+                  <a:srgbClr val="FFFFFF"/>
+                </a:solidFill>
+                <a:latin typeface="Plus Jakarta Sans"/>
+              </a:defRPr>
+            </a:pPr>
+            <a:r>
+              <a:t>   High-contrast dismiss triggers allow seniors to cancel alarm tones as soon as they are safe.</a:t>
+            </a:r>
+          </a:p>
+        </p:txBody>
+      </p:sp>
+      <p:pic>
+        <p:nvPicPr>
+          <p:cNvPr id="4" name="Picture 3" descr="sos_alert.png"/>
+          <p:cNvPicPr>
+            <a:picLocks noChangeAspect="1"/>
+          </p:cNvPicPr>
+          <p:nvPr/>
+        </p:nvPicPr>
+        <p:blipFill>
+          <a:blip r:embed="rId2"/>
+          <a:stretch>
+            <a:fillRect/>
+          </a:stretch>
+        </p:blipFill>
+        <p:spPr>
+          <a:xfrm>
+            <a:off x="6858000" y="1645920"/>
+            <a:ext cx="4114800" cy="3657600"/>
+          </a:xfrm>
+          <a:prstGeom prst="rect">
+            <a:avLst/>
+          </a:prstGeom>
+        </p:spPr>
+      </p:pic>
     </p:spTree>
   </p:cSld>
   <p:clrMapOvr>

</xml_diff>

<commit_message>
docs: use side-by-side design layout on cover and conclusion slides and simplify copy to be human-understandable
</commit_message>
<xml_diff>
--- a/medicare_presentation.pptx
+++ b/medicare_presentation.pptx
@@ -3113,8 +3113,8 @@
         </p:nvSpPr>
         <p:spPr>
           <a:xfrm>
-            <a:off x="914400" y="1828800"/>
-            <a:ext cx="10360152" cy="3657600"/>
+            <a:off x="914400" y="1645920"/>
+            <a:ext cx="6400800" cy="4114800"/>
           </a:xfrm>
           <a:prstGeom prst="rect">
             <a:avLst/>
@@ -3127,8 +3127,8 @@
           </a:bodyPr>
           <a:lstStyle/>
           <a:p>
-            <a:pPr algn="ctr">
-              <a:defRPr sz="5400" b="1">
+            <a:pPr>
+              <a:defRPr sz="4800" b="1">
                 <a:solidFill>
                   <a:srgbClr val="0D9488"/>
                 </a:solidFill>
@@ -3140,11 +3140,11 @@
             </a:r>
           </a:p>
           <a:p>
-            <a:pPr algn="ctr">
+            <a:pPr>
               <a:spcBef>
                 <a:spcPts val="1500"/>
               </a:spcBef>
-              <a:defRPr sz="2400" b="1">
+              <a:defRPr sz="2200" b="1">
                 <a:solidFill>
                   <a:srgbClr val="FFFFFF"/>
                 </a:solidFill>
@@ -3156,9 +3156,9 @@
             </a:r>
           </a:p>
           <a:p>
-            <a:pPr algn="ctr">
+            <a:pPr>
               <a:spcBef>
-                <a:spcPts val="1000"/>
+                <a:spcPts val="1500"/>
               </a:spcBef>
               <a:defRPr sz="1600">
                 <a:solidFill>
@@ -3168,11 +3168,35 @@
               </a:defRPr>
             </a:pPr>
             <a:r>
-              <a:t>Project Presentation Slide Deck</a:t>
-            </a:r>
-          </a:p>
-        </p:txBody>
-      </p:sp>
+              <a:t>An offline-first medication reminder and emergency SOS alert portal built for seniors and caregivers.</a:t>
+            </a:r>
+          </a:p>
+        </p:txBody>
+      </p:sp>
+      <p:pic>
+        <p:nvPicPr>
+          <p:cNvPr id="3" name="Picture 2" descr="splash_screen.png"/>
+          <p:cNvPicPr>
+            <a:picLocks noChangeAspect="1"/>
+          </p:cNvPicPr>
+          <p:nvPr/>
+        </p:nvPicPr>
+        <p:blipFill>
+          <a:blip r:embed="rId2"/>
+          <a:stretch>
+            <a:fillRect/>
+          </a:stretch>
+        </p:blipFill>
+        <p:spPr>
+          <a:xfrm>
+            <a:off x="8229600" y="1097280"/>
+            <a:ext cx="2286000" cy="4572000"/>
+          </a:xfrm>
+          <a:prstGeom prst="rect">
+            <a:avLst/>
+          </a:prstGeom>
+        </p:spPr>
+      </p:pic>
     </p:spTree>
   </p:cSld>
   <p:clrMapOvr>
@@ -3207,8 +3231,8 @@
         </p:nvSpPr>
         <p:spPr>
           <a:xfrm>
-            <a:off x="914400" y="2011680"/>
-            <a:ext cx="10360152" cy="3200400"/>
+            <a:off x="914400" y="1645920"/>
+            <a:ext cx="5943600" cy="4114800"/>
           </a:xfrm>
           <a:prstGeom prst="rect">
             <a:avLst/>
@@ -3221,7 +3245,7 @@
           </a:bodyPr>
           <a:lstStyle/>
           <a:p>
-            <a:pPr algn="ctr">
+            <a:pPr>
               <a:defRPr sz="3600" b="1">
                 <a:solidFill>
                   <a:srgbClr val="0D9488"/>
@@ -3230,15 +3254,15 @@
               </a:defRPr>
             </a:pPr>
             <a:r>
-              <a:t>Healthcare Adherence Re-imagined</a:t>
-            </a:r>
-          </a:p>
-          <a:p>
-            <a:pPr algn="ctr">
+              <a:t>Simple, Safe &amp; Reliable</a:t>
+            </a:r>
+          </a:p>
+          <a:p>
+            <a:pPr>
               <a:spcBef>
                 <a:spcPts val="1500"/>
               </a:spcBef>
-              <a:defRPr sz="2000" b="1">
+              <a:defRPr sz="1800">
                 <a:solidFill>
                   <a:srgbClr val="FFFFFF"/>
                 </a:solidFill>
@@ -3246,13 +3270,13 @@
               </a:defRPr>
             </a:pPr>
             <a:r>
-              <a:t>Offline-First, Zero click latency, and Immediate Caretaker SOS Alerts</a:t>
-            </a:r>
-          </a:p>
-          <a:p>
-            <a:pPr algn="ctr">
+              <a:t>Medicare bridges the gap between patient compliance and caregiver peace-of-mind by resolving cloud delays, network timeouts, and language barriers.</a:t>
+            </a:r>
+          </a:p>
+          <a:p>
+            <a:pPr>
               <a:spcBef>
-                <a:spcPts val="1000"/>
+                <a:spcPts val="1500"/>
               </a:spcBef>
               <a:defRPr sz="1600">
                 <a:solidFill>
@@ -3262,11 +3286,35 @@
               </a:defRPr>
             </a:pPr>
             <a:r>
-              <a:t>Live Deployment: medicine-reminder-navy-phi.vercel.app</a:t>
-            </a:r>
-          </a:p>
-        </p:txBody>
-      </p:sp>
+              <a:t>Live App URL: medicine-reminder-navy-phi.vercel.app</a:t>
+            </a:r>
+          </a:p>
+        </p:txBody>
+      </p:sp>
+      <p:pic>
+        <p:nvPicPr>
+          <p:cNvPr id="3" name="Picture 2" descr="dose_due.png"/>
+          <p:cNvPicPr>
+            <a:picLocks noChangeAspect="1"/>
+          </p:cNvPicPr>
+          <p:nvPr/>
+        </p:nvPicPr>
+        <p:blipFill>
+          <a:blip r:embed="rId2"/>
+          <a:stretch>
+            <a:fillRect/>
+          </a:stretch>
+        </p:blipFill>
+        <p:spPr>
+          <a:xfrm>
+            <a:off x="7315200" y="1645920"/>
+            <a:ext cx="3840480" cy="3291840"/>
+          </a:xfrm>
+          <a:prstGeom prst="rect">
+            <a:avLst/>
+          </a:prstGeom>
+        </p:spPr>
+      </p:pic>
     </p:spTree>
   </p:cSld>
   <p:clrMapOvr>
@@ -3353,7 +3401,7 @@
           <a:p>
             <a:pPr>
               <a:spcAft>
-                <a:spcPts val="1500"/>
+                <a:spcPts val="2000"/>
               </a:spcAft>
               <a:defRPr sz="1800">
                 <a:solidFill>
@@ -3363,29 +3411,13 @@
               </a:defRPr>
             </a:pPr>
             <a:r>
-              <a:t>The MediCare Reminder System (Aegis Health) is an offline-first, highly responsive web application built to enhance medication compliance and ensure safety for elderly patients.</a:t>
+              <a:t>MediCare is a simple, smart web application designed to help elderly patients manage their daily pills without confusion. It acts as a safety companion that works offline even without internet, speaks reminders aloud, and keeps caregivers updated in real-time.</a:t>
             </a:r>
           </a:p>
           <a:p>
             <a:pPr>
               <a:spcAft>
-                <a:spcPts val="1000"/>
-              </a:spcAft>
-              <a:defRPr sz="1800" b="1">
-                <a:solidFill>
-                  <a:srgbClr val="0D9488"/>
-                </a:solidFill>
-                <a:latin typeface="Outfit"/>
-              </a:defRPr>
-            </a:pPr>
-            <a:r>
-              <a:t>Key highlights include:</a:t>
-            </a:r>
-          </a:p>
-          <a:p>
-            <a:pPr>
-              <a:spcAft>
-                <a:spcPts val="800"/>
+                <a:spcPts val="1200"/>
               </a:spcAft>
               <a:defRPr sz="1600">
                 <a:solidFill>
@@ -3395,13 +3427,13 @@
               </a:defRPr>
             </a:pPr>
             <a:r>
-              <a:t>• Optimistic UI updates through local Firestore IndexedDB caching, eliminating database save lags.</a:t>
+              <a:t>✓ No Internet? No Problem! — Updates are saved instantly in the browser cache first and sync with the database later when online.</a:t>
             </a:r>
           </a:p>
           <a:p>
             <a:pPr>
               <a:spcAft>
-                <a:spcPts val="800"/>
+                <a:spcPts val="1200"/>
               </a:spcAft>
               <a:defRPr sz="1600">
                 <a:solidFill>
@@ -3411,13 +3443,13 @@
               </a:defRPr>
             </a:pPr>
             <a:r>
-              <a:t>• Dynamic multi-language support localized in Telugu and Hindi for dynamic checkboxes and details.</a:t>
+              <a:t>✓ Hindi &amp; Telugu Support — Translates instructions, logs, and buttons into local languages so seniors can easily understand them.</a:t>
             </a:r>
           </a:p>
           <a:p>
             <a:pPr>
               <a:spcAft>
-                <a:spcPts val="800"/>
+                <a:spcPts val="1200"/>
               </a:spcAft>
               <a:defRPr sz="1600">
                 <a:solidFill>
@@ -3427,23 +3459,7 @@
               </a:defRPr>
             </a:pPr>
             <a:r>
-              <a:t>• Tactile dose reminders with built-in instant dialing links for primary doctors and emergency caretakers.</a:t>
-            </a:r>
-          </a:p>
-          <a:p>
-            <a:pPr>
-              <a:spcAft>
-                <a:spcPts val="800"/>
-              </a:spcAft>
-              <a:defRPr sz="1600">
-                <a:solidFill>
-                  <a:srgbClr val="9CA3AF"/>
-                </a:solidFill>
-                <a:latin typeface="Plus Jakarta Sans"/>
-              </a:defRPr>
-            </a:pPr>
-            <a:r>
-              <a:t>• Emergency SOS triggers linked to real-time caregiver grids to monitor compliance and check-ups.</a:t>
+              <a:t>✓ One-Tap Doctor Dials — Direct calling actions placed directly inside the notifications to contact clinicians immediately.</a:t>
             </a:r>
           </a:p>
         </p:txBody>
@@ -3505,7 +3521,7 @@
               </a:defRPr>
             </a:pPr>
             <a:r>
-              <a:t>2. Problem Statement</a:t>
+              <a:t>2. The Problem Statement</a:t>
             </a:r>
           </a:p>
         </p:txBody>
@@ -3544,7 +3560,7 @@
               </a:defRPr>
             </a:pPr>
             <a:r>
-              <a:t>Seniors and patients facing complex prescription schedules encounter high safety risks due to several challenges:</a:t>
+              <a:t>Standard health websites and mobile apps fail to support senior citizens because of four main barriers:</a:t>
             </a:r>
           </a:p>
           <a:p>
@@ -3560,7 +3576,7 @@
               </a:defRPr>
             </a:pPr>
             <a:r>
-              <a:t>• Medication Forgetfulness</a:t>
+              <a:t>• Forgetfulness &amp; Safety Hazards</a:t>
             </a:r>
           </a:p>
           <a:p>
@@ -3573,7 +3589,7 @@
               </a:defRPr>
             </a:pPr>
             <a:r>
-              <a:t>   Elderly patients skip scheduled doses or double-dose medication due to cognitive or memory declines.</a:t>
+              <a:t>   Seniors often miss scheduled pills, take wrong quantities, or accidentally take the same dose twice.</a:t>
             </a:r>
           </a:p>
           <a:p>
@@ -3589,7 +3605,7 @@
               </a:defRPr>
             </a:pPr>
             <a:r>
-              <a:t>• Sluggish Portal Latencies</a:t>
+              <a:t>• Laggy Online Apps</a:t>
             </a:r>
           </a:p>
           <a:p>
@@ -3602,7 +3618,7 @@
               </a:defRPr>
             </a:pPr>
             <a:r>
-              <a:t>   Standard online portals block the UI and lag when trying to save data during unstable network operations.</a:t>
+              <a:t>   Most applications freeze or show errors when internet is slow or disconnected, blocking user updates.</a:t>
             </a:r>
           </a:p>
           <a:p>
@@ -3618,7 +3634,7 @@
               </a:defRPr>
             </a:pPr>
             <a:r>
-              <a:t>• No Direct Dials in Emergency</a:t>
+              <a:t>• English-Only Interfaces</a:t>
             </a:r>
           </a:p>
           <a:p>
@@ -3631,7 +3647,7 @@
               </a:defRPr>
             </a:pPr>
             <a:r>
-              <a:t>   Traditional checklists do not offer instant emergency calling features for caregivers or doctors during crises.</a:t>
+              <a:t>   Instruction portals are hard to navigate for seniors who only speak or read Hindi or Telugu.</a:t>
             </a:r>
           </a:p>
           <a:p>
@@ -3647,7 +3663,7 @@
               </a:defRPr>
             </a:pPr>
             <a:r>
-              <a:t>• Lack of Localization</a:t>
+              <a:t>• Difficult Emergency Actions</a:t>
             </a:r>
           </a:p>
           <a:p>
@@ -3660,7 +3676,7 @@
               </a:defRPr>
             </a:pPr>
             <a:r>
-              <a:t>   Important instructions and checklists do not translate dynamic database entries into local languages (Telugu &amp; Hindi).</a:t>
+              <a:t>   Traditional checkers do not offer immediate direct-dial buttons to call doctors or alert caretakers during crises.</a:t>
             </a:r>
           </a:p>
         </p:txBody>
@@ -3761,7 +3777,7 @@
               </a:defRPr>
             </a:pPr>
             <a:r>
-              <a:t>Existing Systems</a:t>
+              <a:t>Existing Systems (The Old Way)</a:t>
             </a:r>
           </a:p>
           <a:p>
@@ -3777,7 +3793,7 @@
               </a:defRPr>
             </a:pPr>
             <a:r>
-              <a:t>• Manual paper logs or static spreadsheets subject to loss or misplacement.</a:t>
+              <a:t>• Manual paper logs that are easily lost or misplaced.</a:t>
             </a:r>
           </a:p>
           <a:p>
@@ -3793,7 +3809,7 @@
               </a:defRPr>
             </a:pPr>
             <a:r>
-              <a:t>• Cloud-only apps that freeze during slow internet operations and throw database errors.</a:t>
+              <a:t>• Apps freeze and block user actions when database syncing takes too long.</a:t>
             </a:r>
           </a:p>
           <a:p>
@@ -3809,7 +3825,7 @@
               </a:defRPr>
             </a:pPr>
             <a:r>
-              <a:t>• Static checklists that cannot be easily read aloud or customized.</a:t>
+              <a:t>• No simple panic triggers or automated caregiver sync updates.</a:t>
             </a:r>
           </a:p>
           <a:p>
@@ -3825,7 +3841,7 @@
               </a:defRPr>
             </a:pPr>
             <a:r>
-              <a:t>• English-only platforms that pose barriers to regional elderly users.</a:t>
+              <a:t>• No local translation options for rural users.</a:t>
             </a:r>
           </a:p>
         </p:txBody>
@@ -3864,7 +3880,7 @@
               </a:defRPr>
             </a:pPr>
             <a:r>
-              <a:t>Proposed System</a:t>
+              <a:t>Proposed System (Medicare)</a:t>
             </a:r>
           </a:p>
           <a:p>
@@ -3880,7 +3896,7 @@
               </a:defRPr>
             </a:pPr>
             <a:r>
-              <a:t>✓ Zero-Lag optimistic saving backed by Firestore Offline Persistence.</a:t>
+              <a:t>✓ Zero Database Lag: Browser cache saves inputs instantly.</a:t>
             </a:r>
           </a:p>
           <a:p>
@@ -3896,7 +3912,7 @@
               </a:defRPr>
             </a:pPr>
             <a:r>
-              <a:t>✓ Instant tactile feedback: 50ms active button scale transitions and 100ms snappy modal openings.</a:t>
+              <a:t>✓ 0.05s button active feedback and fast modal animations.</a:t>
             </a:r>
           </a:p>
           <a:p>
@@ -3912,7 +3928,7 @@
               </a:defRPr>
             </a:pPr>
             <a:r>
-              <a:t>✓ Built-in Speak Aloud reader, Double Doctor Dialing button, and one-tap SOS Emergency modal.</a:t>
+              <a:t>✓ One-click SOS sirens, direct clinician dialing, and Speak Aloud helper.</a:t>
             </a:r>
           </a:p>
           <a:p>
@@ -3928,7 +3944,7 @@
               </a:defRPr>
             </a:pPr>
             <a:r>
-              <a:t>✓ Dynamic localization translating state checklists fully in Telugu and Hindi.</a:t>
+              <a:t>✓ Fully dynamic Telugu and Hindi localizations.</a:t>
             </a:r>
           </a:p>
         </p:txBody>
@@ -4045,7 +4061,7 @@
               </a:defRPr>
             </a:pPr>
             <a:r>
-              <a:t>• Patient / Caretaker Device: Mobile, Tablet, Laptop, or PC.</a:t>
+              <a:t>• User Devices: Smartphone, Tablet, or PC.</a:t>
             </a:r>
           </a:p>
           <a:p>
@@ -4061,7 +4077,7 @@
               </a:defRPr>
             </a:pPr>
             <a:r>
-              <a:t>• Processor: Intel Core i3 or similar Mobile SoC.</a:t>
+              <a:t>• Processor: Intel Core i3 or mobile SoC equivalent.</a:t>
             </a:r>
           </a:p>
           <a:p>
@@ -4077,7 +4093,7 @@
               </a:defRPr>
             </a:pPr>
             <a:r>
-              <a:t>• RAM: 2 GB minimum (4 GB recommended).</a:t>
+              <a:t>• System Memory: 2 GB RAM minimum.</a:t>
             </a:r>
           </a:p>
           <a:p>
@@ -4093,7 +4109,7 @@
               </a:defRPr>
             </a:pPr>
             <a:r>
-              <a:t>• Storage: 100 MB available local disk storage.</a:t>
+              <a:t>• Storage: 100 MB local disk storage.</a:t>
             </a:r>
           </a:p>
           <a:p>
@@ -4109,7 +4125,7 @@
               </a:defRPr>
             </a:pPr>
             <a:r>
-              <a:t>• Display: Touchscreen display (for mobile usability).</a:t>
+              <a:t>• Screen: Touch display recommended for mobile ease.</a:t>
             </a:r>
           </a:p>
         </p:txBody>
@@ -4164,7 +4180,7 @@
               </a:defRPr>
             </a:pPr>
             <a:r>
-              <a:t>• Operating System: Windows 10/11, macOS, Android, or iOS.</a:t>
+              <a:t>• OS: Windows, macOS, Android, or iOS.</a:t>
             </a:r>
           </a:p>
           <a:p>
@@ -4180,7 +4196,7 @@
               </a:defRPr>
             </a:pPr>
             <a:r>
-              <a:t>• Web Browser: Google Chrome, Safari, Firefox, or Microsoft Edge.</a:t>
+              <a:t>• Web Browsers: Chrome, Safari, Edge, or Firefox.</a:t>
             </a:r>
           </a:p>
           <a:p>
@@ -4196,7 +4212,7 @@
               </a:defRPr>
             </a:pPr>
             <a:r>
-              <a:t>• Development Stack: HTML5, CSS3 (Vanilla), ES6+ Javascript.</a:t>
+              <a:t>• Dev Tools: HTML5, CSS3, ES6+ Javascript.</a:t>
             </a:r>
           </a:p>
           <a:p>
@@ -4212,7 +4228,7 @@
               </a:defRPr>
             </a:pPr>
             <a:r>
-              <a:t>• Database Layer: Cloud Firestore &amp; Local browser IndexedDB.</a:t>
+              <a:t>• Database Engine: Cloud Firestore with IndexedDB.</a:t>
             </a:r>
           </a:p>
           <a:p>
@@ -4228,7 +4244,7 @@
               </a:defRPr>
             </a:pPr>
             <a:r>
-              <a:t>• Hosting Environment: Vercel Production Server.</a:t>
+              <a:t>• Deployment Host: Vercel Production Environment.</a:t>
             </a:r>
           </a:p>
         </p:txBody>
@@ -4329,13 +4345,13 @@
               </a:defRPr>
             </a:pPr>
             <a:r>
-              <a:t>The platform separates interface events, caching operations, and database synchronization to ensure lag-free usability:</a:t>
+              <a:t>The platform is separated into three simple components to guarantee speed and security:</a:t>
             </a:r>
           </a:p>
           <a:p>
             <a:pPr>
               <a:spcBef>
-                <a:spcPts val="800"/>
+                <a:spcPts val="1000"/>
               </a:spcBef>
               <a:defRPr sz="1800" b="1">
                 <a:solidFill>
@@ -4345,7 +4361,7 @@
               </a:defRPr>
             </a:pPr>
             <a:r>
-              <a:t>1. User Interface Layer (HTML5/CSS3)</a:t>
+              <a:t>1. User Interface (Front End)</a:t>
             </a:r>
           </a:p>
           <a:p>
@@ -4358,13 +4374,13 @@
               </a:defRPr>
             </a:pPr>
             <a:r>
-              <a:t>   Captures direct tap events, displays checklists, handles language changes, and animates alarms in 100ms.</a:t>
+              <a:t>   Captures taps, plays siren warnings, and formats translated text instantly.</a:t>
             </a:r>
           </a:p>
           <a:p>
             <a:pPr>
               <a:spcBef>
-                <a:spcPts val="800"/>
+                <a:spcPts val="1000"/>
               </a:spcBef>
               <a:defRPr sz="1800" b="1">
                 <a:solidFill>
@@ -4374,7 +4390,7 @@
               </a:defRPr>
             </a:pPr>
             <a:r>
-              <a:t>2. Local Persistence Store (IndexedDB Cache)</a:t>
+              <a:t>2. Local Cache (IndexedDB)</a:t>
             </a:r>
           </a:p>
           <a:p>
@@ -4387,13 +4403,13 @@
               </a:defRPr>
             </a:pPr>
             <a:r>
-              <a:t>   Maintains offline copy of user state. Reads and writes update here immediately, preventing thread blockages.</a:t>
+              <a:t>   Saves and retrieves data instantly in browser memory, preventing database save locks.</a:t>
             </a:r>
           </a:p>
           <a:p>
             <a:pPr>
               <a:spcBef>
-                <a:spcPts val="800"/>
+                <a:spcPts val="1000"/>
               </a:spcBef>
               <a:defRPr sz="1800" b="1">
                 <a:solidFill>
@@ -4403,7 +4419,7 @@
               </a:defRPr>
             </a:pPr>
             <a:r>
-              <a:t>3. Cloud Sync Manager (Firestore Engine)</a:t>
+              <a:t>3. Cloud Sync (Firebase Engine)</a:t>
             </a:r>
           </a:p>
           <a:p>
@@ -4416,36 +4432,7 @@
               </a:defRPr>
             </a:pPr>
             <a:r>
-              <a:t>   Handles credentials, caregiver monitoring updates, and state syncing. Automatically falls back to local storage if network fails.</a:t>
-            </a:r>
-          </a:p>
-          <a:p>
-            <a:pPr>
-              <a:spcBef>
-                <a:spcPts val="800"/>
-              </a:spcBef>
-              <a:defRPr sz="1800" b="1">
-                <a:solidFill>
-                  <a:srgbClr val="0D9488"/>
-                </a:solidFill>
-                <a:latin typeface="Outfit"/>
-              </a:defRPr>
-            </a:pPr>
-            <a:r>
-              <a:t>4. Caregiver Live Grid</a:t>
-            </a:r>
-          </a:p>
-          <a:p>
-            <a:pPr>
-              <a:defRPr sz="1500">
-                <a:solidFill>
-                  <a:srgbClr val="FFFFFF"/>
-                </a:solidFill>
-                <a:latin typeface="Plus Jakarta Sans"/>
-              </a:defRPr>
-            </a:pPr>
-            <a:r>
-              <a:t>   Listens dynamically to states updates to output compliance metrics, streaks, and check-up notifications.</a:t>
+              <a:t>   Uploads local logs to the caregiver database automatically when internet is active.</a:t>
             </a:r>
           </a:p>
         </p:txBody>
@@ -4546,7 +4533,7 @@
               </a:defRPr>
             </a:pPr>
             <a:r>
-              <a:t>• Modern Visual Style</a:t>
+              <a:t>• Modern App Welcome Screen</a:t>
             </a:r>
           </a:p>
           <a:p>
@@ -4562,7 +4549,7 @@
               </a:defRPr>
             </a:pPr>
             <a:r>
-              <a:t>   Curated dark background with glowing accent colors matching patient and caregiver entry routes.</a:t>
+              <a:t>   Deep charcoal theme styled to match mobile form factors natively.</a:t>
             </a:r>
           </a:p>
           <a:p>
@@ -4578,7 +4565,7 @@
               </a:defRPr>
             </a:pPr>
             <a:r>
-              <a:t>• Adaptive Branding Identity</a:t>
+              <a:t>• Two Access Portals</a:t>
             </a:r>
           </a:p>
           <a:p>
@@ -4594,7 +4581,7 @@
               </a:defRPr>
             </a:pPr>
             <a:r>
-              <a:t>   Branding splash introducing 'Your Health, Our Priority' slogan within responsive mobile containers.</a:t>
+              <a:t>   Gives simple routes for Patients to view cards and Caregivers to monitor logs.</a:t>
             </a:r>
           </a:p>
           <a:p>
@@ -4610,7 +4597,7 @@
               </a:defRPr>
             </a:pPr>
             <a:r>
-              <a:t>• Simple Selection Portals</a:t>
+              <a:t>• Bold Color Accents</a:t>
             </a:r>
           </a:p>
           <a:p>
@@ -4626,7 +4613,7 @@
               </a:defRPr>
             </a:pPr>
             <a:r>
-              <a:t>   Clean buttons letting patients log in or caretakers switch to status grids immediately.</a:t>
+              <a:t>   Vibrant colors make text readable for senior citizens.</a:t>
             </a:r>
           </a:p>
         </p:txBody>
@@ -4751,7 +4738,7 @@
               </a:defRPr>
             </a:pPr>
             <a:r>
-              <a:t>• Overlay Warning Panel</a:t>
+              <a:t>• Overlay Reminder Card</a:t>
             </a:r>
           </a:p>
           <a:p>
@@ -4767,7 +4754,7 @@
               </a:defRPr>
             </a:pPr>
             <a:r>
-              <a:t>   Alarm due cards intercept the main workspace immediately. Shows bold title, category form, and timing logs.</a:t>
+              <a:t>   Alert opens immediately when a scheduled medicine is due, showing pill quantity and details.</a:t>
             </a:r>
           </a:p>
           <a:p>
@@ -4783,7 +4770,7 @@
               </a:defRPr>
             </a:pPr>
             <a:r>
-              <a:t>• Quick Dials &amp; Skip Actions</a:t>
+              <a:t>• Instant Doctor Call Button</a:t>
             </a:r>
           </a:p>
           <a:p>
@@ -4799,7 +4786,7 @@
               </a:defRPr>
             </a:pPr>
             <a:r>
-              <a:t>   Integrated Call Doctor buttons allow seniors to dial primary clinics with one simple tap.</a:t>
+              <a:t>   Let seniors click to call their primary doctor immediately during complications.</a:t>
             </a:r>
           </a:p>
           <a:p>
@@ -4815,7 +4802,7 @@
               </a:defRPr>
             </a:pPr>
             <a:r>
-              <a:t>• Snappy Interaction Speeds</a:t>
+              <a:t>• Tactile Feedback Actions</a:t>
             </a:r>
           </a:p>
           <a:p>
@@ -4831,7 +4818,7 @@
               </a:defRPr>
             </a:pPr>
             <a:r>
-              <a:t>   0.05s touch feedbacks and 100ms popup openings ensure senior actions save immediately.</a:t>
+              <a:t>   Mark pill intake Taken or Snooze it for 10 minutes with instant tap responses.</a:t>
             </a:r>
           </a:p>
         </p:txBody>
@@ -4956,7 +4943,7 @@
               </a:defRPr>
             </a:pPr>
             <a:r>
-              <a:t>• Critical Warn siren Alert</a:t>
+              <a:t>• Loud Local Siren Alarms</a:t>
             </a:r>
           </a:p>
           <a:p>
@@ -4972,7 +4959,7 @@
               </a:defRPr>
             </a:pPr>
             <a:r>
-              <a:t>   One tap triggers emergency sirening, alerts caretakers, and opens active health alerts dashboard.</a:t>
+              <a:t>   Plays siren warnings and notifies caregiver dashboards immediately.</a:t>
             </a:r>
           </a:p>
           <a:p>
@@ -4988,7 +4975,7 @@
               </a:defRPr>
             </a:pPr>
             <a:r>
-              <a:t>• Helper Public Contacts</a:t>
+              <a:t>• Direct Calling Action List</a:t>
             </a:r>
           </a:p>
           <a:p>
@@ -5004,7 +4991,7 @@
               </a:defRPr>
             </a:pPr>
             <a:r>
-              <a:t>   Clearly visible links for direct dials to emergency contact numbers and medical helpline lines (108 / 112).</a:t>
+              <a:t>   Aggregated emergency contacts, doctor numbers, and ambulances (108 / 112).</a:t>
             </a:r>
           </a:p>
           <a:p>
@@ -5020,7 +5007,7 @@
               </a:defRPr>
             </a:pPr>
             <a:r>
-              <a:t>• Snap Deactivate Button</a:t>
+              <a:t>• Quick Dismiss Trigger</a:t>
             </a:r>
           </a:p>
           <a:p>
@@ -5036,7 +5023,7 @@
               </a:defRPr>
             </a:pPr>
             <a:r>
-              <a:t>   High-contrast dismiss triggers allow seniors to cancel alarm tones as soon as they are safe.</a:t>
+              <a:t>   High-contrast deactivate button lets the user cancel sirens as soon as they are safe.</a:t>
             </a:r>
           </a:p>
         </p:txBody>

</xml_diff>

<commit_message>
docs: update Problem Statement slide with user verbatim explanation
</commit_message>
<xml_diff>
--- a/medicare_presentation.pptx
+++ b/medicare_presentation.pptx
@@ -3521,7 +3521,7 @@
               </a:defRPr>
             </a:pPr>
             <a:r>
-              <a:t>2. The Problem Statement</a:t>
+              <a:t>2. Problem Statement</a:t>
             </a:r>
           </a:p>
         </p:txBody>
@@ -3550,133 +3550,33 @@
           <a:p>
             <a:pPr>
               <a:spcAft>
-                <a:spcPts val="1500"/>
+                <a:spcPts val="2500"/>
               </a:spcAft>
-              <a:defRPr sz="1800">
-                <a:solidFill>
-                  <a:srgbClr val="9CA3AF"/>
+              <a:defRPr sz="2000">
+                <a:solidFill>
+                  <a:srgbClr val="FFFFFF"/>
                 </a:solidFill>
                 <a:latin typeface="Plus Jakarta Sans"/>
               </a:defRPr>
             </a:pPr>
             <a:r>
-              <a:t>Standard health websites and mobile apps fail to support senior citizens because of four main barriers:</a:t>
+              <a:t>Many people forget to take their medicines on time because of busy schedules, old age, or memory problems. Missing medicines can cause serious health issues and reduce treatment effectiveness. Patients need a simple system that reminds them about medicine timings regularly.</a:t>
             </a:r>
           </a:p>
           <a:p>
             <a:pPr>
               <a:spcBef>
-                <a:spcPts val="800"/>
+                <a:spcPts val="1000"/>
               </a:spcBef>
-              <a:defRPr sz="1800" b="1">
-                <a:solidFill>
-                  <a:srgbClr val="F43F5E"/>
-                </a:solidFill>
-                <a:latin typeface="Outfit"/>
-              </a:defRPr>
-            </a:pPr>
-            <a:r>
-              <a:t>• Forgetfulness &amp; Safety Hazards</a:t>
-            </a:r>
-          </a:p>
-          <a:p>
-            <a:pPr>
-              <a:defRPr sz="1500">
-                <a:solidFill>
-                  <a:srgbClr val="FFFFFF"/>
+              <a:defRPr sz="2000">
+                <a:solidFill>
+                  <a:srgbClr val="0D9488"/>
                 </a:solidFill>
                 <a:latin typeface="Plus Jakarta Sans"/>
               </a:defRPr>
             </a:pPr>
             <a:r>
-              <a:t>   Seniors often miss scheduled pills, take wrong quantities, or accidentally take the same dose twice.</a:t>
-            </a:r>
-          </a:p>
-          <a:p>
-            <a:pPr>
-              <a:spcBef>
-                <a:spcPts val="800"/>
-              </a:spcBef>
-              <a:defRPr sz="1800" b="1">
-                <a:solidFill>
-                  <a:srgbClr val="F43F5E"/>
-                </a:solidFill>
-                <a:latin typeface="Outfit"/>
-              </a:defRPr>
-            </a:pPr>
-            <a:r>
-              <a:t>• Laggy Online Apps</a:t>
-            </a:r>
-          </a:p>
-          <a:p>
-            <a:pPr>
-              <a:defRPr sz="1500">
-                <a:solidFill>
-                  <a:srgbClr val="FFFFFF"/>
-                </a:solidFill>
-                <a:latin typeface="Plus Jakarta Sans"/>
-              </a:defRPr>
-            </a:pPr>
-            <a:r>
-              <a:t>   Most applications freeze or show errors when internet is slow or disconnected, blocking user updates.</a:t>
-            </a:r>
-          </a:p>
-          <a:p>
-            <a:pPr>
-              <a:spcBef>
-                <a:spcPts val="800"/>
-              </a:spcBef>
-              <a:defRPr sz="1800" b="1">
-                <a:solidFill>
-                  <a:srgbClr val="F43F5E"/>
-                </a:solidFill>
-                <a:latin typeface="Outfit"/>
-              </a:defRPr>
-            </a:pPr>
-            <a:r>
-              <a:t>• English-Only Interfaces</a:t>
-            </a:r>
-          </a:p>
-          <a:p>
-            <a:pPr>
-              <a:defRPr sz="1500">
-                <a:solidFill>
-                  <a:srgbClr val="FFFFFF"/>
-                </a:solidFill>
-                <a:latin typeface="Plus Jakarta Sans"/>
-              </a:defRPr>
-            </a:pPr>
-            <a:r>
-              <a:t>   Instruction portals are hard to navigate for seniors who only speak or read Hindi or Telugu.</a:t>
-            </a:r>
-          </a:p>
-          <a:p>
-            <a:pPr>
-              <a:spcBef>
-                <a:spcPts val="800"/>
-              </a:spcBef>
-              <a:defRPr sz="1800" b="1">
-                <a:solidFill>
-                  <a:srgbClr val="F43F5E"/>
-                </a:solidFill>
-                <a:latin typeface="Outfit"/>
-              </a:defRPr>
-            </a:pPr>
-            <a:r>
-              <a:t>• Difficult Emergency Actions</a:t>
-            </a:r>
-          </a:p>
-          <a:p>
-            <a:pPr>
-              <a:defRPr sz="1500">
-                <a:solidFill>
-                  <a:srgbClr val="FFFFFF"/>
-                </a:solidFill>
-                <a:latin typeface="Plus Jakarta Sans"/>
-              </a:defRPr>
-            </a:pPr>
-            <a:r>
-              <a:t>   Traditional checkers do not offer immediate direct-dial buttons to call doctors or alert caretakers during crises.</a:t>
+              <a:t>The Medicine Reminder App is developed to solve this problem by giving alerts and reminders to users at the correct time. This helps people take medicines properly and improve their health care management.</a:t>
             </a:r>
           </a:p>
         </p:txBody>

</xml_diff>

<commit_message>
docs: embed System Architecture diagram in presentation slide 6
</commit_message>
<xml_diff>
--- a/medicare_presentation.pptx
+++ b/medicare_presentation.pptx
@@ -4220,7 +4220,7 @@
         <p:spPr>
           <a:xfrm>
             <a:off x="914400" y="1645920"/>
-            <a:ext cx="10360152" cy="4572000"/>
+            <a:ext cx="5486400" cy="4572000"/>
           </a:xfrm>
           <a:prstGeom prst="rect">
             <a:avLst/>
@@ -4234,22 +4234,6 @@
           <a:lstStyle/>
           <a:p>
             <a:pPr>
-              <a:spcAft>
-                <a:spcPts val="2000"/>
-              </a:spcAft>
-              <a:defRPr sz="1800">
-                <a:solidFill>
-                  <a:srgbClr val="9CA3AF"/>
-                </a:solidFill>
-                <a:latin typeface="Plus Jakarta Sans"/>
-              </a:defRPr>
-            </a:pPr>
-            <a:r>
-              <a:t>The platform is separated into three simple components to guarantee speed and security:</a:t>
-            </a:r>
-          </a:p>
-          <a:p>
-            <a:pPr>
               <a:spcBef>
                 <a:spcPts val="1000"/>
               </a:spcBef>
@@ -4261,11 +4245,14 @@
               </a:defRPr>
             </a:pPr>
             <a:r>
-              <a:t>1. User Interface (Front End)</a:t>
-            </a:r>
-          </a:p>
-          <a:p>
-            <a:pPr>
+              <a:t>• User Interface Layer</a:t>
+            </a:r>
+          </a:p>
+          <a:p>
+            <a:pPr>
+              <a:spcAft>
+                <a:spcPts val="1000"/>
+              </a:spcAft>
               <a:defRPr sz="1500">
                 <a:solidFill>
                   <a:srgbClr val="FFFFFF"/>
@@ -4274,7 +4261,7 @@
               </a:defRPr>
             </a:pPr>
             <a:r>
-              <a:t>   Captures taps, plays siren warnings, and formats translated text instantly.</a:t>
+              <a:t>   Displays checklists, manages alerts, and executes custom Telugu/Hindi localizations.</a:t>
             </a:r>
           </a:p>
           <a:p>
@@ -4290,11 +4277,14 @@
               </a:defRPr>
             </a:pPr>
             <a:r>
-              <a:t>2. Local Cache (IndexedDB)</a:t>
-            </a:r>
-          </a:p>
-          <a:p>
-            <a:pPr>
+              <a:t>• Application Logic</a:t>
+            </a:r>
+          </a:p>
+          <a:p>
+            <a:pPr>
+              <a:spcAft>
+                <a:spcPts val="1000"/>
+              </a:spcAft>
               <a:defRPr sz="1500">
                 <a:solidFill>
                   <a:srgbClr val="FFFFFF"/>
@@ -4303,7 +4293,7 @@
               </a:defRPr>
             </a:pPr>
             <a:r>
-              <a:t>   Saves and retrieves data instantly in browser memory, preventing database save locks.</a:t>
+              <a:t>   Operates authentication services, alert notifications engine, and medicine schedule check modules.</a:t>
             </a:r>
           </a:p>
           <a:p>
@@ -4319,11 +4309,14 @@
               </a:defRPr>
             </a:pPr>
             <a:r>
-              <a:t>3. Cloud Sync (Firebase Engine)</a:t>
-            </a:r>
-          </a:p>
-          <a:p>
-            <a:pPr>
+              <a:t>• Database &amp; Hosting</a:t>
+            </a:r>
+          </a:p>
+          <a:p>
+            <a:pPr>
+              <a:spcAft>
+                <a:spcPts val="1000"/>
+              </a:spcAft>
               <a:defRPr sz="1500">
                 <a:solidFill>
                   <a:srgbClr val="FFFFFF"/>
@@ -4332,11 +4325,35 @@
               </a:defRPr>
             </a:pPr>
             <a:r>
-              <a:t>   Uploads local logs to the caregiver database automatically when internet is active.</a:t>
-            </a:r>
-          </a:p>
-        </p:txBody>
-      </p:sp>
+              <a:t>   Maintains local persistence cache and updates Firestore cloud logs, hosted live on Vercel.</a:t>
+            </a:r>
+          </a:p>
+        </p:txBody>
+      </p:sp>
+      <p:pic>
+        <p:nvPicPr>
+          <p:cNvPr id="4" name="Picture 3" descr="system_architecture.png"/>
+          <p:cNvPicPr>
+            <a:picLocks noChangeAspect="1"/>
+          </p:cNvPicPr>
+          <p:nvPr/>
+        </p:nvPicPr>
+        <p:blipFill>
+          <a:blip r:embed="rId2"/>
+          <a:stretch>
+            <a:fillRect/>
+          </a:stretch>
+        </p:blipFill>
+        <p:spPr>
+          <a:xfrm>
+            <a:off x="6675120" y="1645920"/>
+            <a:ext cx="4754880" cy="4023360"/>
+          </a:xfrm>
+          <a:prstGeom prst="rect">
+            <a:avLst/>
+          </a:prstGeom>
+        </p:spPr>
+      </p:pic>
     </p:spTree>
   </p:cSld>
   <p:clrMapOvr>

</xml_diff>

<commit_message>
docs: add guide G. Bhagya Lakshmi and team members table to cover slide
</commit_message>
<xml_diff>
--- a/medicare_presentation.pptx
+++ b/medicare_presentation.pptx
@@ -3113,8 +3113,8 @@
         </p:nvSpPr>
         <p:spPr>
           <a:xfrm>
-            <a:off x="914400" y="1645920"/>
-            <a:ext cx="6400800" cy="4114800"/>
+            <a:off x="914400" y="1371600"/>
+            <a:ext cx="5486400" cy="4572000"/>
           </a:xfrm>
           <a:prstGeom prst="rect">
             <a:avLst/>
@@ -3128,7 +3128,7 @@
           <a:lstStyle/>
           <a:p>
             <a:pPr>
-              <a:defRPr sz="4800" b="1">
+              <a:defRPr sz="4400" b="1">
                 <a:solidFill>
                   <a:srgbClr val="0D9488"/>
                 </a:solidFill>
@@ -3136,67 +3136,382 @@
               </a:defRPr>
             </a:pPr>
             <a:r>
-              <a:t>MediCare Reminder System</a:t>
+              <a:t>Medicine Reminder System</a:t>
             </a:r>
           </a:p>
           <a:p>
             <a:pPr>
               <a:spcBef>
-                <a:spcPts val="1500"/>
+                <a:spcPts val="1000"/>
+              </a:spcBef>
+              <a:defRPr sz="2000" b="1">
+                <a:solidFill>
+                  <a:srgbClr val="FFFFFF"/>
+                </a:solidFill>
+                <a:latin typeface="Outfit"/>
+              </a:defRPr>
+            </a:pPr>
+            <a:r>
+              <a:t>Community Based Project</a:t>
+            </a:r>
+          </a:p>
+          <a:p>
+            <a:pPr>
+              <a:spcBef>
+                <a:spcPts val="3000"/>
+              </a:spcBef>
+              <a:defRPr sz="1400">
+                <a:solidFill>
+                  <a:srgbClr val="9CA3AF"/>
+                </a:solidFill>
+                <a:latin typeface="Plus Jakarta Sans"/>
+              </a:defRPr>
+            </a:pPr>
+            <a:r>
+              <a:t>Project Guide:</a:t>
+            </a:r>
+          </a:p>
+          <a:p>
+            <a:pPr>
+              <a:spcBef>
+                <a:spcPts val="500"/>
               </a:spcBef>
               <a:defRPr sz="2200" b="1">
                 <a:solidFill>
                   <a:srgbClr val="FFFFFF"/>
                 </a:solidFill>
-                <a:latin typeface="Plus Jakarta Sans"/>
-              </a:defRPr>
-            </a:pPr>
-            <a:r>
-              <a:t>Your Health, Our Priority</a:t>
-            </a:r>
-          </a:p>
-          <a:p>
-            <a:pPr>
-              <a:spcBef>
-                <a:spcPts val="1500"/>
-              </a:spcBef>
-              <a:defRPr sz="1600">
-                <a:solidFill>
-                  <a:srgbClr val="9CA3AF"/>
-                </a:solidFill>
-                <a:latin typeface="Plus Jakarta Sans"/>
-              </a:defRPr>
-            </a:pPr>
-            <a:r>
-              <a:t>An offline-first medication reminder and emergency SOS alert portal built for seniors and caregivers.</a:t>
-            </a:r>
-          </a:p>
-        </p:txBody>
-      </p:sp>
-      <p:pic>
-        <p:nvPicPr>
-          <p:cNvPr id="3" name="Picture 2" descr="splash_screen.png"/>
-          <p:cNvPicPr>
-            <a:picLocks noChangeAspect="1"/>
-          </p:cNvPicPr>
+                <a:latin typeface="Outfit"/>
+              </a:defRPr>
+            </a:pPr>
+            <a:r>
+              <a:t>G. Bhagya Lakshmi</a:t>
+            </a:r>
+          </a:p>
+        </p:txBody>
+      </p:sp>
+      <p:graphicFrame>
+        <p:nvGraphicFramePr>
+          <p:cNvPr id="3" name="Table 2"/>
+          <p:cNvGraphicFramePr>
+            <a:graphicFrameLocks noGrp="1"/>
+          </p:cNvGraphicFramePr>
           <p:nvPr/>
-        </p:nvPicPr>
-        <p:blipFill>
-          <a:blip r:embed="rId2"/>
-          <a:stretch>
-            <a:fillRect/>
-          </a:stretch>
-        </p:blipFill>
-        <p:spPr>
-          <a:xfrm>
-            <a:off x="8229600" y="1097280"/>
-            <a:ext cx="2286000" cy="4572000"/>
-          </a:xfrm>
-          <a:prstGeom prst="rect">
-            <a:avLst/>
-          </a:prstGeom>
-        </p:spPr>
-      </p:pic>
+        </p:nvGraphicFramePr>
+        <p:xfrm>
+          <a:off x="6858000" y="2011680"/>
+          <a:ext cx="4572000" cy="2286000"/>
+        </p:xfrm>
+        <a:graphic>
+          <a:graphicData uri="http://schemas.openxmlformats.org/drawingml/2006/table">
+            <a:tbl>
+              <a:tblPr firstRow="1" bandRow="1">
+                <a:tableStyleId>{5C22544A-7EE6-4342-B048-85BDC9FD1C3A}</a:tableStyleId>
+              </a:tblPr>
+              <a:tblGrid>
+                <a:gridCol w="731520"/>
+                <a:gridCol w="1920240"/>
+                <a:gridCol w="1920240"/>
+              </a:tblGrid>
+              <a:tr h="571500">
+                <a:tc>
+                  <a:txBody>
+                    <a:bodyPr/>
+                    <a:lstStyle/>
+                    <a:p>
+                      <a:pPr algn="ctr">
+                        <a:defRPr sz="1400" b="1">
+                          <a:solidFill>
+                            <a:srgbClr val="FFFFFF"/>
+                          </a:solidFill>
+                          <a:latin typeface="Outfit"/>
+                        </a:defRPr>
+                      </a:pPr>
+                      <a:r>
+                        <a:t>S.No</a:t>
+                      </a:r>
+                    </a:p>
+                  </a:txBody>
+                  <a:tcPr>
+                    <a:solidFill>
+                      <a:srgbClr val="0D9488"/>
+                    </a:solidFill>
+                  </a:tcPr>
+                </a:tc>
+                <a:tc>
+                  <a:txBody>
+                    <a:bodyPr/>
+                    <a:lstStyle/>
+                    <a:p>
+                      <a:pPr algn="ctr">
+                        <a:defRPr sz="1400" b="1">
+                          <a:solidFill>
+                            <a:srgbClr val="FFFFFF"/>
+                          </a:solidFill>
+                          <a:latin typeface="Outfit"/>
+                        </a:defRPr>
+                      </a:pPr>
+                      <a:r>
+                        <a:t>Roll Number</a:t>
+                      </a:r>
+                    </a:p>
+                  </a:txBody>
+                  <a:tcPr>
+                    <a:solidFill>
+                      <a:srgbClr val="0D9488"/>
+                    </a:solidFill>
+                  </a:tcPr>
+                </a:tc>
+                <a:tc>
+                  <a:txBody>
+                    <a:bodyPr/>
+                    <a:lstStyle/>
+                    <a:p>
+                      <a:pPr algn="ctr">
+                        <a:defRPr sz="1400" b="1">
+                          <a:solidFill>
+                            <a:srgbClr val="FFFFFF"/>
+                          </a:solidFill>
+                          <a:latin typeface="Outfit"/>
+                        </a:defRPr>
+                      </a:pPr>
+                      <a:r>
+                        <a:t>Name</a:t>
+                      </a:r>
+                    </a:p>
+                  </a:txBody>
+                  <a:tcPr>
+                    <a:solidFill>
+                      <a:srgbClr val="0D9488"/>
+                    </a:solidFill>
+                  </a:tcPr>
+                </a:tc>
+              </a:tr>
+              <a:tr h="571500">
+                <a:tc>
+                  <a:txBody>
+                    <a:bodyPr/>
+                    <a:lstStyle/>
+                    <a:p>
+                      <a:pPr algn="ctr">
+                        <a:defRPr sz="1300">
+                          <a:solidFill>
+                            <a:srgbClr val="FFFFFF"/>
+                          </a:solidFill>
+                          <a:latin typeface="Plus Jakarta Sans"/>
+                        </a:defRPr>
+                      </a:pPr>
+                      <a:r>
+                        <a:t>1.</a:t>
+                      </a:r>
+                    </a:p>
+                  </a:txBody>
+                  <a:tcPr>
+                    <a:solidFill>
+                      <a:srgbClr val="121826"/>
+                    </a:solidFill>
+                  </a:tcPr>
+                </a:tc>
+                <a:tc>
+                  <a:txBody>
+                    <a:bodyPr/>
+                    <a:lstStyle/>
+                    <a:p>
+                      <a:pPr algn="ctr">
+                        <a:defRPr sz="1300">
+                          <a:solidFill>
+                            <a:srgbClr val="FFFFFF"/>
+                          </a:solidFill>
+                          <a:latin typeface="Plus Jakarta Sans"/>
+                        </a:defRPr>
+                      </a:pPr>
+                      <a:r>
+                        <a:t>24331A07C6</a:t>
+                      </a:r>
+                    </a:p>
+                  </a:txBody>
+                  <a:tcPr>
+                    <a:solidFill>
+                      <a:srgbClr val="121826"/>
+                    </a:solidFill>
+                  </a:tcPr>
+                </a:tc>
+                <a:tc>
+                  <a:txBody>
+                    <a:bodyPr/>
+                    <a:lstStyle/>
+                    <a:p>
+                      <a:pPr algn="ctr">
+                        <a:defRPr sz="1300">
+                          <a:solidFill>
+                            <a:srgbClr val="FFFFFF"/>
+                          </a:solidFill>
+                          <a:latin typeface="Plus Jakarta Sans"/>
+                        </a:defRPr>
+                      </a:pPr>
+                      <a:r>
+                        <a:t>V.DILEEP</a:t>
+                      </a:r>
+                    </a:p>
+                  </a:txBody>
+                  <a:tcPr>
+                    <a:solidFill>
+                      <a:srgbClr val="121826"/>
+                    </a:solidFill>
+                  </a:tcPr>
+                </a:tc>
+              </a:tr>
+              <a:tr h="571500">
+                <a:tc>
+                  <a:txBody>
+                    <a:bodyPr/>
+                    <a:lstStyle/>
+                    <a:p>
+                      <a:pPr algn="ctr">
+                        <a:defRPr sz="1300">
+                          <a:solidFill>
+                            <a:srgbClr val="FFFFFF"/>
+                          </a:solidFill>
+                          <a:latin typeface="Plus Jakarta Sans"/>
+                        </a:defRPr>
+                      </a:pPr>
+                      <a:r>
+                        <a:t>2.</a:t>
+                      </a:r>
+                    </a:p>
+                  </a:txBody>
+                  <a:tcPr>
+                    <a:solidFill>
+                      <a:srgbClr val="121826"/>
+                    </a:solidFill>
+                  </a:tcPr>
+                </a:tc>
+                <a:tc>
+                  <a:txBody>
+                    <a:bodyPr/>
+                    <a:lstStyle/>
+                    <a:p>
+                      <a:pPr algn="ctr">
+                        <a:defRPr sz="1300">
+                          <a:solidFill>
+                            <a:srgbClr val="FFFFFF"/>
+                          </a:solidFill>
+                          <a:latin typeface="Plus Jakarta Sans"/>
+                        </a:defRPr>
+                      </a:pPr>
+                      <a:r>
+                        <a:t>25335A0710</a:t>
+                      </a:r>
+                    </a:p>
+                  </a:txBody>
+                  <a:tcPr>
+                    <a:solidFill>
+                      <a:srgbClr val="121826"/>
+                    </a:solidFill>
+                  </a:tcPr>
+                </a:tc>
+                <a:tc>
+                  <a:txBody>
+                    <a:bodyPr/>
+                    <a:lstStyle/>
+                    <a:p>
+                      <a:pPr algn="ctr">
+                        <a:defRPr sz="1300">
+                          <a:solidFill>
+                            <a:srgbClr val="FFFFFF"/>
+                          </a:solidFill>
+                          <a:latin typeface="Plus Jakarta Sans"/>
+                        </a:defRPr>
+                      </a:pPr>
+                      <a:r>
+                        <a:t>P.HEMA</a:t>
+                      </a:r>
+                    </a:p>
+                  </a:txBody>
+                  <a:tcPr>
+                    <a:solidFill>
+                      <a:srgbClr val="121826"/>
+                    </a:solidFill>
+                  </a:tcPr>
+                </a:tc>
+              </a:tr>
+              <a:tr h="571500">
+                <a:tc>
+                  <a:txBody>
+                    <a:bodyPr/>
+                    <a:lstStyle/>
+                    <a:p>
+                      <a:pPr algn="ctr">
+                        <a:defRPr sz="1300">
+                          <a:solidFill>
+                            <a:srgbClr val="FFFFFF"/>
+                          </a:solidFill>
+                          <a:latin typeface="Plus Jakarta Sans"/>
+                        </a:defRPr>
+                      </a:pPr>
+                      <a:r>
+                        <a:t>3.</a:t>
+                      </a:r>
+                    </a:p>
+                  </a:txBody>
+                  <a:tcPr>
+                    <a:solidFill>
+                      <a:srgbClr val="121826"/>
+                    </a:solidFill>
+                  </a:tcPr>
+                </a:tc>
+                <a:tc>
+                  <a:txBody>
+                    <a:bodyPr/>
+                    <a:lstStyle/>
+                    <a:p>
+                      <a:pPr algn="ctr">
+                        <a:defRPr sz="1300">
+                          <a:solidFill>
+                            <a:srgbClr val="FFFFFF"/>
+                          </a:solidFill>
+                          <a:latin typeface="Plus Jakarta Sans"/>
+                        </a:defRPr>
+                      </a:pPr>
+                      <a:r>
+                        <a:t>24331A0776</a:t>
+                      </a:r>
+                    </a:p>
+                  </a:txBody>
+                  <a:tcPr>
+                    <a:solidFill>
+                      <a:srgbClr val="121826"/>
+                    </a:solidFill>
+                  </a:tcPr>
+                </a:tc>
+                <a:tc>
+                  <a:txBody>
+                    <a:bodyPr/>
+                    <a:lstStyle/>
+                    <a:p>
+                      <a:pPr algn="ctr">
+                        <a:defRPr sz="1300">
+                          <a:solidFill>
+                            <a:srgbClr val="FFFFFF"/>
+                          </a:solidFill>
+                          <a:latin typeface="Plus Jakarta Sans"/>
+                        </a:defRPr>
+                      </a:pPr>
+                      <a:r>
+                        <a:t>M.SHARIF</a:t>
+                      </a:r>
+                    </a:p>
+                  </a:txBody>
+                  <a:tcPr>
+                    <a:solidFill>
+                      <a:srgbClr val="121826"/>
+                    </a:solidFill>
+                  </a:tcPr>
+                </a:tc>
+              </a:tr>
+            </a:tbl>
+          </a:graphicData>
+        </a:graphic>
+      </p:graphicFrame>
     </p:spTree>
   </p:cSld>
   <p:clrMapOvr>
@@ -3459,7 +3774,7 @@
               </a:defRPr>
             </a:pPr>
             <a:r>
-              <a:t>✓ One-Tap Doctor Dials — Direct calling actions placed directly inside the notifications to contact clinicians immediately.</a:t>
+              <a:t>✓ One-Tap Doctor Dials — Direct calling actions placed directly inside the notifications to contact clinics immediately.</a:t>
             </a:r>
           </a:p>
         </p:txBody>

</xml_diff>